<commit_message>
corrijo version de windows
</commit_message>
<xml_diff>
--- a/outputs/tarea3_llms_locales.pptx
+++ b/outputs/tarea3_llms_locales.pptx
@@ -2,20 +2,20 @@
 <file path=ppt/presentation.xml><?xml version="1.0" encoding="utf-8"?>
 <p:presentation xmlns:p="http://schemas.openxmlformats.org/presentationml/2006/main">
   <p:sldMasterIdLst>
-    <p:sldMasterId xmlns:r="http://schemas.openxmlformats.org/officeDocument/2006/relationships" id="2147483648" r:id="R47450394bdc847a0"/>
+    <p:sldMasterId xmlns:r="http://schemas.openxmlformats.org/officeDocument/2006/relationships" id="2147483648" r:id="Raf078455250b4557"/>
   </p:sldMasterIdLst>
   <p:notesMasterIdLst>
-    <p:notesMasterId xmlns:r="http://schemas.openxmlformats.org/officeDocument/2006/relationships" r:id="Rbfa839ce953c40c3"/>
+    <p:notesMasterId xmlns:r="http://schemas.openxmlformats.org/officeDocument/2006/relationships" r:id="R89da511e0caa4ed4"/>
   </p:notesMasterIdLst>
   <p:sldIdLst>
-    <p:sldId xmlns:r="http://schemas.openxmlformats.org/officeDocument/2006/relationships" id="256" r:id="R9d7312e1161e4ec8"/>
-    <p:sldId xmlns:r="http://schemas.openxmlformats.org/officeDocument/2006/relationships" id="257" r:id="R99b8b25379bc4f7f"/>
-    <p:sldId xmlns:r="http://schemas.openxmlformats.org/officeDocument/2006/relationships" id="258" r:id="Ra746bc8d146d4dd5"/>
-    <p:sldId xmlns:r="http://schemas.openxmlformats.org/officeDocument/2006/relationships" id="259" r:id="R473dfa87ade347a2"/>
-    <p:sldId xmlns:r="http://schemas.openxmlformats.org/officeDocument/2006/relationships" id="260" r:id="Rd0d3841bf00a49ab"/>
-    <p:sldId xmlns:r="http://schemas.openxmlformats.org/officeDocument/2006/relationships" id="261" r:id="R4d3e82fad2ef4a49"/>
-    <p:sldId xmlns:r="http://schemas.openxmlformats.org/officeDocument/2006/relationships" id="262" r:id="R98303b90e41c4380"/>
-    <p:sldId xmlns:r="http://schemas.openxmlformats.org/officeDocument/2006/relationships" id="263" r:id="R18bc3f7db81c4f92"/>
+    <p:sldId xmlns:r="http://schemas.openxmlformats.org/officeDocument/2006/relationships" id="256" r:id="Rf19d860bc4724b0a"/>
+    <p:sldId xmlns:r="http://schemas.openxmlformats.org/officeDocument/2006/relationships" id="257" r:id="Rca43d87561374f69"/>
+    <p:sldId xmlns:r="http://schemas.openxmlformats.org/officeDocument/2006/relationships" id="258" r:id="Rc11751954e53461e"/>
+    <p:sldId xmlns:r="http://schemas.openxmlformats.org/officeDocument/2006/relationships" id="259" r:id="R65d14dc65046407d"/>
+    <p:sldId xmlns:r="http://schemas.openxmlformats.org/officeDocument/2006/relationships" id="260" r:id="R8378c3554c0b43e9"/>
+    <p:sldId xmlns:r="http://schemas.openxmlformats.org/officeDocument/2006/relationships" id="261" r:id="R09e0339192e14029"/>
+    <p:sldId xmlns:r="http://schemas.openxmlformats.org/officeDocument/2006/relationships" id="262" r:id="R867ccdcb5182471b"/>
+    <p:sldId xmlns:r="http://schemas.openxmlformats.org/officeDocument/2006/relationships" id="263" r:id="Rb8f3ca92ee0247e6"/>
   </p:sldIdLst>
   <p:sldSz cx="12192000" cy="6858000"/>
   <p:notesSz cx="6858000" cy="9144000"/>
@@ -1070,7 +1070,7 @@
   </p:cSld>
   <p:clrMap bg1="lt1" tx1="dk1" bg2="lt2" tx2="dk2" accent1="accent1" accent2="accent2" accent3="accent3" accent4="accent4" accent5="accent5" accent6="accent6" hlink="hlink" folHlink="folHlink"/>
   <p:sldLayoutIdLst>
-    <p:sldLayoutId xmlns:r="http://schemas.openxmlformats.org/officeDocument/2006/relationships" id="2147483649" r:id="Read182bd2ec54b98"/>
+    <p:sldLayoutId xmlns:r="http://schemas.openxmlformats.org/officeDocument/2006/relationships" id="2147483649" r:id="Rb3bdd6819734491e"/>
   </p:sldLayoutIdLst>
   <p:txStyles>
     <p:titleStyle>
@@ -1600,10 +1600,8 @@
 <file path=ppt/slides/charts/chart1.xml><?xml version="1.0" encoding="utf-8"?>
 <c:chartSpace xmlns:c="http://schemas.openxmlformats.org/drawingml/2006/chart">
   <c:lang val="en-US"/>
-  <c:roundedCorners val="0"/>
   <c:chart>
     <c:plotArea>
-      <c:layout/>
       <c:barChart>
         <c:barDir val="col"/>
         <c:varyColors val="0"/>
@@ -1618,15 +1616,7 @@
               <a:srgbClr val="000000"/>
             </a:solidFill>
           </c:spPr>
-          <c:dLbls>
-            <c:showLegendKey val="0"/>
-            <c:showVal val="0"/>
-            <c:showCatName val="0"/>
-            <c:showSerName val="0"/>
-            <c:showPercent val="0"/>
-            <c:showBubbleSize val="0"/>
-            <c:showLeaderLines val="0"/>
-          </c:dLbls>
+          <c:dLbls/>
           <c:cat>
             <c:strLit>
               <c:ptCount val="3"/>
@@ -1668,15 +1658,7 @@
               <a:srgbClr val="FF6B35"/>
             </a:solidFill>
           </c:spPr>
-          <c:dLbls>
-            <c:showLegendKey val="0"/>
-            <c:showVal val="0"/>
-            <c:showCatName val="0"/>
-            <c:showSerName val="0"/>
-            <c:showPercent val="0"/>
-            <c:showBubbleSize val="0"/>
-            <c:showLeaderLines val="0"/>
-          </c:dLbls>
+          <c:dLbls/>
           <c:cat>
             <c:strLit>
               <c:ptCount val="3"/>
@@ -1718,15 +1700,7 @@
               <a:srgbClr val="B8BCC4"/>
             </a:solidFill>
           </c:spPr>
-          <c:dLbls>
-            <c:showLegendKey val="0"/>
-            <c:showVal val="0"/>
-            <c:showCatName val="0"/>
-            <c:showSerName val="0"/>
-            <c:showPercent val="0"/>
-            <c:showBubbleSize val="0"/>
-            <c:showLeaderLines val="0"/>
-          </c:dLbls>
+          <c:dLbls/>
           <c:cat>
             <c:strLit>
               <c:ptCount val="3"/>
@@ -1759,13 +1733,7 @@
         </c:ser>
         <c:dLbls>
           <c:dLblPos val="outEnd"/>
-          <c:showLegendKey val="0"/>
           <c:showVal val="1"/>
-          <c:showCatName val="0"/>
-          <c:showSerName val="0"/>
-          <c:showPercent val="0"/>
-          <c:showBubbleSize val="0"/>
-          <c:showLeaderLines val="0"/>
         </c:dLbls>
         <c:axId val="48650112"/>
         <c:axId val="48672768"/>
@@ -1876,7 +1844,7 @@
           <p:cNvPr id="1" name="">
             <a:extLst xmlns:a="http://schemas.openxmlformats.org/drawingml/2006/main">
               <a:ext uri="{FF2B5EF4-FFF2-40B4-BE49-F238E27FC236}">
-                <a16:creationId xmlns:a16="http://schemas.microsoft.com/office/drawing/2014/main" id="{CFB05273-364F-4503-9CE5-87AF3F095268}"/>
+                <a16:creationId xmlns:a16="http://schemas.microsoft.com/office/drawing/2014/main" id="{668A2959-F2F7-4082-AF26-F3B76A8969E6}"/>
               </a:ext>
             </a:extLst>
           </p:cNvPr>
@@ -1932,7 +1900,7 @@
           <p:cNvPr id="2" name="">
             <a:extLst xmlns:a="http://schemas.openxmlformats.org/drawingml/2006/main">
               <a:ext uri="{FF2B5EF4-FFF2-40B4-BE49-F238E27FC236}">
-                <a16:creationId xmlns:a16="http://schemas.microsoft.com/office/drawing/2014/main" id="{E7975A10-A51F-4ADA-8A38-D023CE19A87B}"/>
+                <a16:creationId xmlns:a16="http://schemas.microsoft.com/office/drawing/2014/main" id="{37B059DC-2EC6-4ABE-AC94-B47D586AF1F6}"/>
               </a:ext>
             </a:extLst>
           </p:cNvPr>
@@ -1963,7 +1931,7 @@
           <p:cNvPr id="3" name="">
             <a:extLst xmlns:a="http://schemas.openxmlformats.org/drawingml/2006/main">
               <a:ext uri="{FF2B5EF4-FFF2-40B4-BE49-F238E27FC236}">
-                <a16:creationId xmlns:a16="http://schemas.microsoft.com/office/drawing/2014/main" id="{362AE33D-009C-42EE-8BBC-045835A2963B}"/>
+                <a16:creationId xmlns:a16="http://schemas.microsoft.com/office/drawing/2014/main" id="{E15288FA-F97B-4D49-9E49-6118F7CEA63F}"/>
               </a:ext>
             </a:extLst>
           </p:cNvPr>
@@ -2019,7 +1987,7 @@
           <p:cNvPr id="4" name="">
             <a:extLst xmlns:a="http://schemas.openxmlformats.org/drawingml/2006/main">
               <a:ext uri="{FF2B5EF4-FFF2-40B4-BE49-F238E27FC236}">
-                <a16:creationId xmlns:a16="http://schemas.microsoft.com/office/drawing/2014/main" id="{6E9B2FED-8CE9-4ACC-99D4-5D936580B5D1}"/>
+                <a16:creationId xmlns:a16="http://schemas.microsoft.com/office/drawing/2014/main" id="{8904D50C-C5C8-4505-B638-079ED8EF88DC}"/>
               </a:ext>
             </a:extLst>
           </p:cNvPr>
@@ -2075,7 +2043,7 @@
           <p:cNvPr id="5" name="">
             <a:extLst xmlns:a="http://schemas.openxmlformats.org/drawingml/2006/main">
               <a:ext uri="{FF2B5EF4-FFF2-40B4-BE49-F238E27FC236}">
-                <a16:creationId xmlns:a16="http://schemas.microsoft.com/office/drawing/2014/main" id="{9D982FF6-59CA-4FBF-92F8-7DD9D41CC5C1}"/>
+                <a16:creationId xmlns:a16="http://schemas.microsoft.com/office/drawing/2014/main" id="{A7E7714C-5ABD-4E42-8FC1-A4D0826F80B8}"/>
               </a:ext>
             </a:extLst>
           </p:cNvPr>
@@ -2106,7 +2074,7 @@
           <p:cNvPr id="6" name="">
             <a:extLst xmlns:a="http://schemas.openxmlformats.org/drawingml/2006/main">
               <a:ext uri="{FF2B5EF4-FFF2-40B4-BE49-F238E27FC236}">
-                <a16:creationId xmlns:a16="http://schemas.microsoft.com/office/drawing/2014/main" id="{84EB0937-D797-4B63-8800-1C3B2697C4DC}"/>
+                <a16:creationId xmlns:a16="http://schemas.microsoft.com/office/drawing/2014/main" id="{DA80E3DC-604A-4BDC-BE00-55A5A8081F8B}"/>
               </a:ext>
             </a:extLst>
           </p:cNvPr>
@@ -2162,7 +2130,7 @@
           <p:cNvPr id="7" name="">
             <a:extLst xmlns:a="http://schemas.openxmlformats.org/drawingml/2006/main">
               <a:ext uri="{FF2B5EF4-FFF2-40B4-BE49-F238E27FC236}">
-                <a16:creationId xmlns:a16="http://schemas.microsoft.com/office/drawing/2014/main" id="{A1D07DC9-5ECE-4704-B6A0-B38508F56FE8}"/>
+                <a16:creationId xmlns:a16="http://schemas.microsoft.com/office/drawing/2014/main" id="{ECF61FDB-992E-427A-B6A3-2089F4340B83}"/>
               </a:ext>
             </a:extLst>
           </p:cNvPr>
@@ -2218,7 +2186,7 @@
           <p:cNvPr id="8" name="">
             <a:extLst xmlns:a="http://schemas.openxmlformats.org/drawingml/2006/main">
               <a:ext uri="{FF2B5EF4-FFF2-40B4-BE49-F238E27FC236}">
-                <a16:creationId xmlns:a16="http://schemas.microsoft.com/office/drawing/2014/main" id="{2D2409D2-D1BF-4113-B89E-D44774CB1B76}"/>
+                <a16:creationId xmlns:a16="http://schemas.microsoft.com/office/drawing/2014/main" id="{EFCD0161-7BC9-426D-A3A6-67840BFB122E}"/>
               </a:ext>
             </a:extLst>
           </p:cNvPr>
@@ -2249,7 +2217,7 @@
           <p:cNvPr id="9" name="">
             <a:extLst xmlns:a="http://schemas.openxmlformats.org/drawingml/2006/main">
               <a:ext uri="{FF2B5EF4-FFF2-40B4-BE49-F238E27FC236}">
-                <a16:creationId xmlns:a16="http://schemas.microsoft.com/office/drawing/2014/main" id="{B103F622-E5B7-4955-BCD1-DCC00A4C08EB}"/>
+                <a16:creationId xmlns:a16="http://schemas.microsoft.com/office/drawing/2014/main" id="{77C145CC-D225-4CC7-AEB8-C2EFE7290E18}"/>
               </a:ext>
             </a:extLst>
           </p:cNvPr>
@@ -2305,7 +2273,7 @@
           <p:cNvPr id="10" name="">
             <a:extLst xmlns:a="http://schemas.openxmlformats.org/drawingml/2006/main">
               <a:ext uri="{FF2B5EF4-FFF2-40B4-BE49-F238E27FC236}">
-                <a16:creationId xmlns:a16="http://schemas.microsoft.com/office/drawing/2014/main" id="{DBD9226B-F3E8-4F5E-9B99-58BE4E91D54E}"/>
+                <a16:creationId xmlns:a16="http://schemas.microsoft.com/office/drawing/2014/main" id="{53B52A08-DB31-4CBC-930C-C5C9C70157E0}"/>
               </a:ext>
             </a:extLst>
           </p:cNvPr>
@@ -2361,7 +2329,7 @@
           <p:cNvPr id="11" name="">
             <a:extLst xmlns:a="http://schemas.openxmlformats.org/drawingml/2006/main">
               <a:ext uri="{FF2B5EF4-FFF2-40B4-BE49-F238E27FC236}">
-                <a16:creationId xmlns:a16="http://schemas.microsoft.com/office/drawing/2014/main" id="{B4C6B870-012E-4C5C-BB2F-45FD54D1D853}"/>
+                <a16:creationId xmlns:a16="http://schemas.microsoft.com/office/drawing/2014/main" id="{70EB9494-1110-4501-9FE8-FBD1010B9FD1}"/>
               </a:ext>
             </a:extLst>
           </p:cNvPr>
@@ -2392,7 +2360,7 @@
           <p:cNvPr id="12" name="">
             <a:extLst xmlns:a="http://schemas.openxmlformats.org/drawingml/2006/main">
               <a:ext uri="{FF2B5EF4-FFF2-40B4-BE49-F238E27FC236}">
-                <a16:creationId xmlns:a16="http://schemas.microsoft.com/office/drawing/2014/main" id="{43C2616E-A7BA-454D-BEAC-108E16638CD7}"/>
+                <a16:creationId xmlns:a16="http://schemas.microsoft.com/office/drawing/2014/main" id="{927553A0-42D6-4068-B446-42C1216FCEF0}"/>
               </a:ext>
             </a:extLst>
           </p:cNvPr>
@@ -2448,7 +2416,7 @@
           <p:cNvPr id="13" name="">
             <a:extLst xmlns:a="http://schemas.openxmlformats.org/drawingml/2006/main">
               <a:ext uri="{FF2B5EF4-FFF2-40B4-BE49-F238E27FC236}">
-                <a16:creationId xmlns:a16="http://schemas.microsoft.com/office/drawing/2014/main" id="{131B863E-11C8-467F-BDBF-E4EEFD251274}"/>
+                <a16:creationId xmlns:a16="http://schemas.microsoft.com/office/drawing/2014/main" id="{1C8D56E4-76E6-4260-B64F-B8F738906043}"/>
               </a:ext>
             </a:extLst>
           </p:cNvPr>
@@ -2504,7 +2472,7 @@
           <p:cNvPr id="14" name="">
             <a:extLst xmlns:a="http://schemas.openxmlformats.org/drawingml/2006/main">
               <a:ext uri="{FF2B5EF4-FFF2-40B4-BE49-F238E27FC236}">
-                <a16:creationId xmlns:a16="http://schemas.microsoft.com/office/drawing/2014/main" id="{EC115B0B-5835-4E48-ACEE-8383CA250B10}"/>
+                <a16:creationId xmlns:a16="http://schemas.microsoft.com/office/drawing/2014/main" id="{C28109D6-3D4A-4556-B8F9-516EEB3FB173}"/>
               </a:ext>
             </a:extLst>
           </p:cNvPr>
@@ -2558,7 +2526,7 @@
     </p:spTree>
     <p:extLst>
       <p:ext uri="{BB962C8B-B14F-4D97-AF65-F5344CB8AC3E}">
-        <p14:creationId xmlns:p14="http://schemas.microsoft.com/office/powerpoint/2010/main" val="2128210763"/>
+        <p14:creationId xmlns:p14="http://schemas.microsoft.com/office/powerpoint/2010/main" val="549841355"/>
       </p:ext>
     </p:extLst>
   </p:cSld>
@@ -2589,7 +2557,7 @@
           <p:cNvPr id="1" name="">
             <a:extLst xmlns:a="http://schemas.openxmlformats.org/drawingml/2006/main">
               <a:ext uri="{FF2B5EF4-FFF2-40B4-BE49-F238E27FC236}">
-                <a16:creationId xmlns:a16="http://schemas.microsoft.com/office/drawing/2014/main" id="{20DE3EC0-DAB6-4902-86AD-57913B6EED12}"/>
+                <a16:creationId xmlns:a16="http://schemas.microsoft.com/office/drawing/2014/main" id="{B8FC4761-B3B7-46FD-9A0B-8B81194B7E10}"/>
               </a:ext>
             </a:extLst>
           </p:cNvPr>
@@ -2645,7 +2613,7 @@
           <p:cNvPr id="2" name="">
             <a:extLst xmlns:a="http://schemas.openxmlformats.org/drawingml/2006/main">
               <a:ext uri="{FF2B5EF4-FFF2-40B4-BE49-F238E27FC236}">
-                <a16:creationId xmlns:a16="http://schemas.microsoft.com/office/drawing/2014/main" id="{744D06E8-28D6-4071-8902-140135480118}"/>
+                <a16:creationId xmlns:a16="http://schemas.microsoft.com/office/drawing/2014/main" id="{73501F93-C93D-4925-893F-192CD338FCC8}"/>
               </a:ext>
             </a:extLst>
           </p:cNvPr>
@@ -2676,7 +2644,7 @@
           <p:cNvPr id="3" name="">
             <a:extLst xmlns:a="http://schemas.openxmlformats.org/drawingml/2006/main">
               <a:ext uri="{FF2B5EF4-FFF2-40B4-BE49-F238E27FC236}">
-                <a16:creationId xmlns:a16="http://schemas.microsoft.com/office/drawing/2014/main" id="{092E1444-BBD4-4510-A5F1-02B0819594A0}"/>
+                <a16:creationId xmlns:a16="http://schemas.microsoft.com/office/drawing/2014/main" id="{5C967098-1B02-4B61-8A3A-FF12C97D7C88}"/>
               </a:ext>
             </a:extLst>
           </p:cNvPr>
@@ -2732,7 +2700,7 @@
           <p:cNvPr id="4" name="">
             <a:extLst xmlns:a="http://schemas.openxmlformats.org/drawingml/2006/main">
               <a:ext uri="{FF2B5EF4-FFF2-40B4-BE49-F238E27FC236}">
-                <a16:creationId xmlns:a16="http://schemas.microsoft.com/office/drawing/2014/main" id="{79232058-28C6-43D2-B961-CCE06BA1FA27}"/>
+                <a16:creationId xmlns:a16="http://schemas.microsoft.com/office/drawing/2014/main" id="{79F5AAA2-77EE-4882-B8E6-E35104067D18}"/>
               </a:ext>
             </a:extLst>
           </p:cNvPr>
@@ -2763,7 +2731,7 @@
           <p:cNvPr id="5" name="">
             <a:extLst xmlns:a="http://schemas.openxmlformats.org/drawingml/2006/main">
               <a:ext uri="{FF2B5EF4-FFF2-40B4-BE49-F238E27FC236}">
-                <a16:creationId xmlns:a16="http://schemas.microsoft.com/office/drawing/2014/main" id="{DBF4C981-5DF7-43D2-820A-9802BF489806}"/>
+                <a16:creationId xmlns:a16="http://schemas.microsoft.com/office/drawing/2014/main" id="{9AB91B44-BAD5-4250-AF4B-22ADA2A4C8B4}"/>
               </a:ext>
             </a:extLst>
           </p:cNvPr>
@@ -2819,7 +2787,7 @@
           <p:cNvPr id="6" name="">
             <a:extLst xmlns:a="http://schemas.openxmlformats.org/drawingml/2006/main">
               <a:ext uri="{FF2B5EF4-FFF2-40B4-BE49-F238E27FC236}">
-                <a16:creationId xmlns:a16="http://schemas.microsoft.com/office/drawing/2014/main" id="{6F51EB0B-0677-4723-A17B-49519A60A407}"/>
+                <a16:creationId xmlns:a16="http://schemas.microsoft.com/office/drawing/2014/main" id="{5015AD98-3425-44C3-8C8B-5C935E875CB7}"/>
               </a:ext>
             </a:extLst>
           </p:cNvPr>
@@ -2850,7 +2818,7 @@
           <p:cNvPr id="7" name="">
             <a:extLst xmlns:a="http://schemas.openxmlformats.org/drawingml/2006/main">
               <a:ext uri="{FF2B5EF4-FFF2-40B4-BE49-F238E27FC236}">
-                <a16:creationId xmlns:a16="http://schemas.microsoft.com/office/drawing/2014/main" id="{0DB54641-B6DE-426C-812C-F6EE6D774978}"/>
+                <a16:creationId xmlns:a16="http://schemas.microsoft.com/office/drawing/2014/main" id="{BA5B7CC6-E8E6-47B2-AA4E-E7BFD905D5CF}"/>
               </a:ext>
             </a:extLst>
           </p:cNvPr>
@@ -2906,7 +2874,7 @@
           <p:cNvPr id="8" name="">
             <a:extLst xmlns:a="http://schemas.openxmlformats.org/drawingml/2006/main">
               <a:ext uri="{FF2B5EF4-FFF2-40B4-BE49-F238E27FC236}">
-                <a16:creationId xmlns:a16="http://schemas.microsoft.com/office/drawing/2014/main" id="{19B76A5A-0E20-4F86-B2B1-5ABC826BBF82}"/>
+                <a16:creationId xmlns:a16="http://schemas.microsoft.com/office/drawing/2014/main" id="{4D21CB67-4B71-45BA-AD62-842AC05C976B}"/>
               </a:ext>
             </a:extLst>
           </p:cNvPr>
@@ -2937,7 +2905,7 @@
           <p:cNvPr id="9" name="">
             <a:extLst xmlns:a="http://schemas.openxmlformats.org/drawingml/2006/main">
               <a:ext uri="{FF2B5EF4-FFF2-40B4-BE49-F238E27FC236}">
-                <a16:creationId xmlns:a16="http://schemas.microsoft.com/office/drawing/2014/main" id="{3E2045D2-D984-4EE8-B5D2-0421E52D6CE2}"/>
+                <a16:creationId xmlns:a16="http://schemas.microsoft.com/office/drawing/2014/main" id="{A7E05469-D189-4A17-9802-D908FF8BDE65}"/>
               </a:ext>
             </a:extLst>
           </p:cNvPr>
@@ -2993,7 +2961,7 @@
           <p:cNvPr id="10" name="">
             <a:extLst xmlns:a="http://schemas.openxmlformats.org/drawingml/2006/main">
               <a:ext uri="{FF2B5EF4-FFF2-40B4-BE49-F238E27FC236}">
-                <a16:creationId xmlns:a16="http://schemas.microsoft.com/office/drawing/2014/main" id="{DFFB8522-14B9-4F2E-9433-B83DC9E083F1}"/>
+                <a16:creationId xmlns:a16="http://schemas.microsoft.com/office/drawing/2014/main" id="{43B122FD-0627-4783-8E74-7BEA471CE418}"/>
               </a:ext>
             </a:extLst>
           </p:cNvPr>
@@ -3024,7 +2992,7 @@
           <p:cNvPr id="11" name="">
             <a:extLst xmlns:a="http://schemas.openxmlformats.org/drawingml/2006/main">
               <a:ext uri="{FF2B5EF4-FFF2-40B4-BE49-F238E27FC236}">
-                <a16:creationId xmlns:a16="http://schemas.microsoft.com/office/drawing/2014/main" id="{5392C5A5-9B3C-457E-9493-DEC37F21F66F}"/>
+                <a16:creationId xmlns:a16="http://schemas.microsoft.com/office/drawing/2014/main" id="{A7CE59CA-C2DB-41C8-A730-C4ED39D1D562}"/>
               </a:ext>
             </a:extLst>
           </p:cNvPr>
@@ -3080,7 +3048,7 @@
           <p:cNvPr id="12" name="">
             <a:extLst xmlns:a="http://schemas.openxmlformats.org/drawingml/2006/main">
               <a:ext uri="{FF2B5EF4-FFF2-40B4-BE49-F238E27FC236}">
-                <a16:creationId xmlns:a16="http://schemas.microsoft.com/office/drawing/2014/main" id="{D3B3052E-0752-4114-80A9-FE6F96A69585}"/>
+                <a16:creationId xmlns:a16="http://schemas.microsoft.com/office/drawing/2014/main" id="{D272E4A1-E781-49C0-870E-DDCBF8903789}"/>
               </a:ext>
             </a:extLst>
           </p:cNvPr>
@@ -3111,7 +3079,7 @@
           <p:cNvPr id="13" name="">
             <a:extLst xmlns:a="http://schemas.openxmlformats.org/drawingml/2006/main">
               <a:ext uri="{FF2B5EF4-FFF2-40B4-BE49-F238E27FC236}">
-                <a16:creationId xmlns:a16="http://schemas.microsoft.com/office/drawing/2014/main" id="{31DDA853-A194-4C94-AFCF-CD8FB69543C1}"/>
+                <a16:creationId xmlns:a16="http://schemas.microsoft.com/office/drawing/2014/main" id="{E3FB904A-8D18-422D-A59C-AF45C26DF32B}"/>
               </a:ext>
             </a:extLst>
           </p:cNvPr>
@@ -3167,7 +3135,7 @@
           <p:cNvPr id="14" name="">
             <a:extLst xmlns:a="http://schemas.openxmlformats.org/drawingml/2006/main">
               <a:ext uri="{FF2B5EF4-FFF2-40B4-BE49-F238E27FC236}">
-                <a16:creationId xmlns:a16="http://schemas.microsoft.com/office/drawing/2014/main" id="{47F335B4-0FF2-423A-B50B-CAF918F415DD}"/>
+                <a16:creationId xmlns:a16="http://schemas.microsoft.com/office/drawing/2014/main" id="{0A894E95-8F7A-451D-BEA7-1A77C757EC12}"/>
               </a:ext>
             </a:extLst>
           </p:cNvPr>
@@ -3198,7 +3166,7 @@
           <p:cNvPr id="15" name="">
             <a:extLst xmlns:a="http://schemas.openxmlformats.org/drawingml/2006/main">
               <a:ext uri="{FF2B5EF4-FFF2-40B4-BE49-F238E27FC236}">
-                <a16:creationId xmlns:a16="http://schemas.microsoft.com/office/drawing/2014/main" id="{5014922A-3B54-4054-9F31-D87EC7F910A2}"/>
+                <a16:creationId xmlns:a16="http://schemas.microsoft.com/office/drawing/2014/main" id="{00F1486E-FC47-4940-8D39-9458A1E1DB69}"/>
               </a:ext>
             </a:extLst>
           </p:cNvPr>
@@ -3254,7 +3222,7 @@
           <p:cNvPr id="16" name="">
             <a:extLst xmlns:a="http://schemas.openxmlformats.org/drawingml/2006/main">
               <a:ext uri="{FF2B5EF4-FFF2-40B4-BE49-F238E27FC236}">
-                <a16:creationId xmlns:a16="http://schemas.microsoft.com/office/drawing/2014/main" id="{844EC1AE-C811-4A85-9CC5-3FC96A14C999}"/>
+                <a16:creationId xmlns:a16="http://schemas.microsoft.com/office/drawing/2014/main" id="{161CDADC-660A-418A-BACA-54FC8F76D774}"/>
               </a:ext>
             </a:extLst>
           </p:cNvPr>
@@ -3285,7 +3253,7 @@
           <p:cNvPr id="17" name="">
             <a:extLst xmlns:a="http://schemas.openxmlformats.org/drawingml/2006/main">
               <a:ext uri="{FF2B5EF4-FFF2-40B4-BE49-F238E27FC236}">
-                <a16:creationId xmlns:a16="http://schemas.microsoft.com/office/drawing/2014/main" id="{42288FEB-A467-4541-97B2-6FD2F90738E4}"/>
+                <a16:creationId xmlns:a16="http://schemas.microsoft.com/office/drawing/2014/main" id="{CC3D458A-F8DC-4BFD-9AB1-C5F2ECD39FE3}"/>
               </a:ext>
             </a:extLst>
           </p:cNvPr>
@@ -3341,7 +3309,7 @@
           <p:cNvPr id="18" name="">
             <a:extLst xmlns:a="http://schemas.openxmlformats.org/drawingml/2006/main">
               <a:ext uri="{FF2B5EF4-FFF2-40B4-BE49-F238E27FC236}">
-                <a16:creationId xmlns:a16="http://schemas.microsoft.com/office/drawing/2014/main" id="{60DE9DEE-DF06-4B08-85F9-5A42963C4703}"/>
+                <a16:creationId xmlns:a16="http://schemas.microsoft.com/office/drawing/2014/main" id="{2C398C2F-587B-41E8-8774-3A575874C763}"/>
               </a:ext>
             </a:extLst>
           </p:cNvPr>
@@ -3372,7 +3340,7 @@
           <p:cNvPr id="19" name="">
             <a:extLst xmlns:a="http://schemas.openxmlformats.org/drawingml/2006/main">
               <a:ext uri="{FF2B5EF4-FFF2-40B4-BE49-F238E27FC236}">
-                <a16:creationId xmlns:a16="http://schemas.microsoft.com/office/drawing/2014/main" id="{E5EBA12E-EF58-41E1-B15A-50D1BE7F7F2C}"/>
+                <a16:creationId xmlns:a16="http://schemas.microsoft.com/office/drawing/2014/main" id="{C5407829-8B75-4804-A74D-B2F6D3B20EC1}"/>
               </a:ext>
             </a:extLst>
           </p:cNvPr>
@@ -3428,7 +3396,7 @@
           <p:cNvPr id="20" name="">
             <a:extLst xmlns:a="http://schemas.openxmlformats.org/drawingml/2006/main">
               <a:ext uri="{FF2B5EF4-FFF2-40B4-BE49-F238E27FC236}">
-                <a16:creationId xmlns:a16="http://schemas.microsoft.com/office/drawing/2014/main" id="{BE62F504-7984-4D39-B2A6-FD25AC9C71B0}"/>
+                <a16:creationId xmlns:a16="http://schemas.microsoft.com/office/drawing/2014/main" id="{C59A217E-1275-44DB-A652-D13E5F0A12A7}"/>
               </a:ext>
             </a:extLst>
           </p:cNvPr>
@@ -3459,7 +3427,7 @@
           <p:cNvPr id="21" name="">
             <a:extLst xmlns:a="http://schemas.openxmlformats.org/drawingml/2006/main">
               <a:ext uri="{FF2B5EF4-FFF2-40B4-BE49-F238E27FC236}">
-                <a16:creationId xmlns:a16="http://schemas.microsoft.com/office/drawing/2014/main" id="{64865D6A-8616-438A-AA54-E68DFCC3695A}"/>
+                <a16:creationId xmlns:a16="http://schemas.microsoft.com/office/drawing/2014/main" id="{958E5A96-DA79-43A2-8F3B-AAFAA75FBF50}"/>
               </a:ext>
             </a:extLst>
           </p:cNvPr>
@@ -3515,7 +3483,7 @@
           <p:cNvPr id="22" name="">
             <a:extLst xmlns:a="http://schemas.openxmlformats.org/drawingml/2006/main">
               <a:ext uri="{FF2B5EF4-FFF2-40B4-BE49-F238E27FC236}">
-                <a16:creationId xmlns:a16="http://schemas.microsoft.com/office/drawing/2014/main" id="{0A3E506B-B9C9-4754-8CE8-B234E5929E1E}"/>
+                <a16:creationId xmlns:a16="http://schemas.microsoft.com/office/drawing/2014/main" id="{784343A5-EC51-4471-B427-F116B46BA0D9}"/>
               </a:ext>
             </a:extLst>
           </p:cNvPr>
@@ -3546,7 +3514,7 @@
           <p:cNvPr id="23" name="">
             <a:extLst xmlns:a="http://schemas.openxmlformats.org/drawingml/2006/main">
               <a:ext uri="{FF2B5EF4-FFF2-40B4-BE49-F238E27FC236}">
-                <a16:creationId xmlns:a16="http://schemas.microsoft.com/office/drawing/2014/main" id="{EB75DFC1-533C-4833-A5AF-E15BC5E2E95C}"/>
+                <a16:creationId xmlns:a16="http://schemas.microsoft.com/office/drawing/2014/main" id="{CC985D13-010A-42BB-90D9-BBE8C4EB5BC4}"/>
               </a:ext>
             </a:extLst>
           </p:cNvPr>
@@ -3600,7 +3568,7 @@
     </p:spTree>
     <p:extLst>
       <p:ext uri="{BB962C8B-B14F-4D97-AF65-F5344CB8AC3E}">
-        <p14:creationId xmlns:p14="http://schemas.microsoft.com/office/powerpoint/2010/main" val="2030818505"/>
+        <p14:creationId xmlns:p14="http://schemas.microsoft.com/office/powerpoint/2010/main" val="1919619821"/>
       </p:ext>
     </p:extLst>
   </p:cSld>
@@ -3631,7 +3599,7 @@
           <p:cNvPr id="1" name="">
             <a:extLst xmlns:a="http://schemas.openxmlformats.org/drawingml/2006/main">
               <a:ext uri="{FF2B5EF4-FFF2-40B4-BE49-F238E27FC236}">
-                <a16:creationId xmlns:a16="http://schemas.microsoft.com/office/drawing/2014/main" id="{B8376C27-061F-4B98-9C2B-621DF7DBAD9A}"/>
+                <a16:creationId xmlns:a16="http://schemas.microsoft.com/office/drawing/2014/main" id="{2ABAF6E4-3B20-46FA-BEB0-373C67553913}"/>
               </a:ext>
             </a:extLst>
           </p:cNvPr>
@@ -3687,7 +3655,7 @@
           <p:cNvPr id="2" name="">
             <a:extLst xmlns:a="http://schemas.openxmlformats.org/drawingml/2006/main">
               <a:ext uri="{FF2B5EF4-FFF2-40B4-BE49-F238E27FC236}">
-                <a16:creationId xmlns:a16="http://schemas.microsoft.com/office/drawing/2014/main" id="{2B9A1601-17E3-48E0-887F-FA19C4C6F2FC}"/>
+                <a16:creationId xmlns:a16="http://schemas.microsoft.com/office/drawing/2014/main" id="{3DE422F4-DF67-4F67-8642-8F80E4DA6FBE}"/>
               </a:ext>
             </a:extLst>
           </p:cNvPr>
@@ -3718,7 +3686,7 @@
           <p:cNvPr id="3" name="">
             <a:extLst xmlns:a="http://schemas.openxmlformats.org/drawingml/2006/main">
               <a:ext uri="{FF2B5EF4-FFF2-40B4-BE49-F238E27FC236}">
-                <a16:creationId xmlns:a16="http://schemas.microsoft.com/office/drawing/2014/main" id="{B6F5AA3F-9E37-4C6F-BC89-2B26AF6A3342}"/>
+                <a16:creationId xmlns:a16="http://schemas.microsoft.com/office/drawing/2014/main" id="{6F957137-5A7B-4B56-976B-4EC491E835A7}"/>
               </a:ext>
             </a:extLst>
           </p:cNvPr>
@@ -3774,7 +3742,7 @@
           <p:cNvPr id="4" name="">
             <a:extLst xmlns:a="http://schemas.openxmlformats.org/drawingml/2006/main">
               <a:ext uri="{FF2B5EF4-FFF2-40B4-BE49-F238E27FC236}">
-                <a16:creationId xmlns:a16="http://schemas.microsoft.com/office/drawing/2014/main" id="{0F8434E5-7C22-441C-AA20-E6228F866760}"/>
+                <a16:creationId xmlns:a16="http://schemas.microsoft.com/office/drawing/2014/main" id="{377FF628-92AA-42EC-A6C5-91F3D32D093D}"/>
               </a:ext>
             </a:extLst>
           </p:cNvPr>
@@ -3807,7 +3775,7 @@
           <p:cNvPr id="5" name="">
             <a:extLst xmlns:a="http://schemas.openxmlformats.org/drawingml/2006/main">
               <a:ext uri="{FF2B5EF4-FFF2-40B4-BE49-F238E27FC236}">
-                <a16:creationId xmlns:a16="http://schemas.microsoft.com/office/drawing/2014/main" id="{A6962593-D2B9-4974-9E3D-8EF4F157DF7B}"/>
+                <a16:creationId xmlns:a16="http://schemas.microsoft.com/office/drawing/2014/main" id="{C3F56C4B-D385-44DD-902D-C75CD661E6EA}"/>
               </a:ext>
             </a:extLst>
           </p:cNvPr>
@@ -3863,7 +3831,7 @@
           <p:cNvPr id="6" name="">
             <a:extLst xmlns:a="http://schemas.openxmlformats.org/drawingml/2006/main">
               <a:ext uri="{FF2B5EF4-FFF2-40B4-BE49-F238E27FC236}">
-                <a16:creationId xmlns:a16="http://schemas.microsoft.com/office/drawing/2014/main" id="{D492E52C-5D84-4D00-B5D3-E94DFC2B4CC1}"/>
+                <a16:creationId xmlns:a16="http://schemas.microsoft.com/office/drawing/2014/main" id="{703E4FB7-6CBF-4EA7-B107-7D724C8E0774}"/>
               </a:ext>
             </a:extLst>
           </p:cNvPr>
@@ -3894,7 +3862,7 @@
           <p:cNvPr id="7" name="">
             <a:extLst xmlns:a="http://schemas.openxmlformats.org/drawingml/2006/main">
               <a:ext uri="{FF2B5EF4-FFF2-40B4-BE49-F238E27FC236}">
-                <a16:creationId xmlns:a16="http://schemas.microsoft.com/office/drawing/2014/main" id="{060AE2DF-2792-4B3C-A30F-95745E744D1E}"/>
+                <a16:creationId xmlns:a16="http://schemas.microsoft.com/office/drawing/2014/main" id="{98F9D81F-58EC-4FC2-A502-9E8028FC9641}"/>
               </a:ext>
             </a:extLst>
           </p:cNvPr>
@@ -3950,7 +3918,7 @@
           <p:cNvPr id="8" name="">
             <a:extLst xmlns:a="http://schemas.openxmlformats.org/drawingml/2006/main">
               <a:ext uri="{FF2B5EF4-FFF2-40B4-BE49-F238E27FC236}">
-                <a16:creationId xmlns:a16="http://schemas.microsoft.com/office/drawing/2014/main" id="{E45A0432-0DC3-4166-928C-63198F3D7FBE}"/>
+                <a16:creationId xmlns:a16="http://schemas.microsoft.com/office/drawing/2014/main" id="{B91832FE-9FA7-447D-BABD-E425B0C9BF76}"/>
               </a:ext>
             </a:extLst>
           </p:cNvPr>
@@ -3983,7 +3951,7 @@
           <p:cNvPr id="9" name="">
             <a:extLst xmlns:a="http://schemas.openxmlformats.org/drawingml/2006/main">
               <a:ext uri="{FF2B5EF4-FFF2-40B4-BE49-F238E27FC236}">
-                <a16:creationId xmlns:a16="http://schemas.microsoft.com/office/drawing/2014/main" id="{8D7A2955-4209-4CB0-82C3-D54C34ECD828}"/>
+                <a16:creationId xmlns:a16="http://schemas.microsoft.com/office/drawing/2014/main" id="{243F6B1A-896D-4A49-96A6-3DF03251F497}"/>
               </a:ext>
             </a:extLst>
           </p:cNvPr>
@@ -4039,7 +4007,7 @@
           <p:cNvPr id="10" name="">
             <a:extLst xmlns:a="http://schemas.openxmlformats.org/drawingml/2006/main">
               <a:ext uri="{FF2B5EF4-FFF2-40B4-BE49-F238E27FC236}">
-                <a16:creationId xmlns:a16="http://schemas.microsoft.com/office/drawing/2014/main" id="{9576468A-199E-41C6-9988-751820F1C30C}"/>
+                <a16:creationId xmlns:a16="http://schemas.microsoft.com/office/drawing/2014/main" id="{7ECC8E39-BD22-4D4A-84A6-7AFEEFF683B9}"/>
               </a:ext>
             </a:extLst>
           </p:cNvPr>
@@ -4070,7 +4038,7 @@
           <p:cNvPr id="11" name="">
             <a:extLst xmlns:a="http://schemas.openxmlformats.org/drawingml/2006/main">
               <a:ext uri="{FF2B5EF4-FFF2-40B4-BE49-F238E27FC236}">
-                <a16:creationId xmlns:a16="http://schemas.microsoft.com/office/drawing/2014/main" id="{8172BB88-8774-4CF6-968A-E76ED3DE832B}"/>
+                <a16:creationId xmlns:a16="http://schemas.microsoft.com/office/drawing/2014/main" id="{05AD800E-F50E-4014-8B57-A6DBE97E7D16}"/>
               </a:ext>
             </a:extLst>
           </p:cNvPr>
@@ -4116,7 +4084,7 @@
                 <a:ea typeface="Helvetica Neue"/>
                 <a:cs typeface="Helvetica Neue"/>
               </a:rPr>
-              <a:t>Windows 10 Pro 2009, 64 bits</a:t>
+              <a:t>Windows 11 Pro Insider Preview 26H2, 64 bits</a:t>
             </a:r>
           </a:p>
         </p:txBody>
@@ -4126,7 +4094,7 @@
           <p:cNvPr id="12" name="">
             <a:extLst xmlns:a="http://schemas.openxmlformats.org/drawingml/2006/main">
               <a:ext uri="{FF2B5EF4-FFF2-40B4-BE49-F238E27FC236}">
-                <a16:creationId xmlns:a16="http://schemas.microsoft.com/office/drawing/2014/main" id="{D4453D68-F14B-46D7-BD8E-6B11794BB4DE}"/>
+                <a16:creationId xmlns:a16="http://schemas.microsoft.com/office/drawing/2014/main" id="{7A354A7E-2CA6-49ED-B59D-A3331846FB75}"/>
               </a:ext>
             </a:extLst>
           </p:cNvPr>
@@ -4159,7 +4127,7 @@
           <p:cNvPr id="13" name="">
             <a:extLst xmlns:a="http://schemas.openxmlformats.org/drawingml/2006/main">
               <a:ext uri="{FF2B5EF4-FFF2-40B4-BE49-F238E27FC236}">
-                <a16:creationId xmlns:a16="http://schemas.microsoft.com/office/drawing/2014/main" id="{3884E26D-10BD-4D33-A95C-F9E75A213FCB}"/>
+                <a16:creationId xmlns:a16="http://schemas.microsoft.com/office/drawing/2014/main" id="{8B28AA1C-C724-4347-8ED9-BE16E7BC85B3}"/>
               </a:ext>
             </a:extLst>
           </p:cNvPr>
@@ -4215,7 +4183,7 @@
           <p:cNvPr id="14" name="">
             <a:extLst xmlns:a="http://schemas.openxmlformats.org/drawingml/2006/main">
               <a:ext uri="{FF2B5EF4-FFF2-40B4-BE49-F238E27FC236}">
-                <a16:creationId xmlns:a16="http://schemas.microsoft.com/office/drawing/2014/main" id="{3C34AA29-57DE-4D91-9E55-A5F2DE5009D8}"/>
+                <a16:creationId xmlns:a16="http://schemas.microsoft.com/office/drawing/2014/main" id="{A36C3EDF-9772-4141-83A8-A06D6A5CBD86}"/>
               </a:ext>
             </a:extLst>
           </p:cNvPr>
@@ -4246,7 +4214,7 @@
           <p:cNvPr id="15" name="">
             <a:extLst xmlns:a="http://schemas.openxmlformats.org/drawingml/2006/main">
               <a:ext uri="{FF2B5EF4-FFF2-40B4-BE49-F238E27FC236}">
-                <a16:creationId xmlns:a16="http://schemas.microsoft.com/office/drawing/2014/main" id="{F2E1ECF5-9F00-4429-B0AE-38B4F35B1BAD}"/>
+                <a16:creationId xmlns:a16="http://schemas.microsoft.com/office/drawing/2014/main" id="{4CF5C504-DFE1-4C97-BA25-B8ED02B7CDB1}"/>
               </a:ext>
             </a:extLst>
           </p:cNvPr>
@@ -4302,7 +4270,7 @@
           <p:cNvPr id="16" name="">
             <a:extLst xmlns:a="http://schemas.openxmlformats.org/drawingml/2006/main">
               <a:ext uri="{FF2B5EF4-FFF2-40B4-BE49-F238E27FC236}">
-                <a16:creationId xmlns:a16="http://schemas.microsoft.com/office/drawing/2014/main" id="{F69343FD-A1F6-426A-8D18-3B3B5A205253}"/>
+                <a16:creationId xmlns:a16="http://schemas.microsoft.com/office/drawing/2014/main" id="{AFA44962-87B6-40F3-942B-6BA6C7E31A6B}"/>
               </a:ext>
             </a:extLst>
           </p:cNvPr>
@@ -4335,7 +4303,7 @@
           <p:cNvPr id="17" name="">
             <a:extLst xmlns:a="http://schemas.openxmlformats.org/drawingml/2006/main">
               <a:ext uri="{FF2B5EF4-FFF2-40B4-BE49-F238E27FC236}">
-                <a16:creationId xmlns:a16="http://schemas.microsoft.com/office/drawing/2014/main" id="{1BAC5D6C-94C7-48B2-913B-A0967194C935}"/>
+                <a16:creationId xmlns:a16="http://schemas.microsoft.com/office/drawing/2014/main" id="{876A1166-DCDE-4314-B82F-C2ACCD3C20F6}"/>
               </a:ext>
             </a:extLst>
           </p:cNvPr>
@@ -4391,7 +4359,7 @@
           <p:cNvPr id="18" name="">
             <a:extLst xmlns:a="http://schemas.openxmlformats.org/drawingml/2006/main">
               <a:ext uri="{FF2B5EF4-FFF2-40B4-BE49-F238E27FC236}">
-                <a16:creationId xmlns:a16="http://schemas.microsoft.com/office/drawing/2014/main" id="{63C51E51-2A76-458C-A48D-89AFD5A1DF09}"/>
+                <a16:creationId xmlns:a16="http://schemas.microsoft.com/office/drawing/2014/main" id="{1D7A47EF-B968-4CEB-9E29-95B4364A8014}"/>
               </a:ext>
             </a:extLst>
           </p:cNvPr>
@@ -4422,7 +4390,7 @@
           <p:cNvPr id="19" name="">
             <a:extLst xmlns:a="http://schemas.openxmlformats.org/drawingml/2006/main">
               <a:ext uri="{FF2B5EF4-FFF2-40B4-BE49-F238E27FC236}">
-                <a16:creationId xmlns:a16="http://schemas.microsoft.com/office/drawing/2014/main" id="{2C1443E3-558C-4CB5-A432-B1E1E79636B8}"/>
+                <a16:creationId xmlns:a16="http://schemas.microsoft.com/office/drawing/2014/main" id="{B8B66767-5EAA-4A46-B5E2-9BC33940468A}"/>
               </a:ext>
             </a:extLst>
           </p:cNvPr>
@@ -4478,7 +4446,7 @@
           <p:cNvPr id="20" name="">
             <a:extLst xmlns:a="http://schemas.openxmlformats.org/drawingml/2006/main">
               <a:ext uri="{FF2B5EF4-FFF2-40B4-BE49-F238E27FC236}">
-                <a16:creationId xmlns:a16="http://schemas.microsoft.com/office/drawing/2014/main" id="{2AEB62B6-8329-49F5-8881-13CF2C74FB4E}"/>
+                <a16:creationId xmlns:a16="http://schemas.microsoft.com/office/drawing/2014/main" id="{8EBDBAE2-5788-4F92-9C89-4FC672DC694B}"/>
               </a:ext>
             </a:extLst>
           </p:cNvPr>
@@ -4511,7 +4479,7 @@
           <p:cNvPr id="21" name="">
             <a:extLst xmlns:a="http://schemas.openxmlformats.org/drawingml/2006/main">
               <a:ext uri="{FF2B5EF4-FFF2-40B4-BE49-F238E27FC236}">
-                <a16:creationId xmlns:a16="http://schemas.microsoft.com/office/drawing/2014/main" id="{712B4CE2-92A1-4300-A9B5-94D6F08113B4}"/>
+                <a16:creationId xmlns:a16="http://schemas.microsoft.com/office/drawing/2014/main" id="{EF3B9A7B-793B-4C70-BE3A-3B7581D1F6B4}"/>
               </a:ext>
             </a:extLst>
           </p:cNvPr>
@@ -4567,7 +4535,7 @@
           <p:cNvPr id="22" name="">
             <a:extLst xmlns:a="http://schemas.openxmlformats.org/drawingml/2006/main">
               <a:ext uri="{FF2B5EF4-FFF2-40B4-BE49-F238E27FC236}">
-                <a16:creationId xmlns:a16="http://schemas.microsoft.com/office/drawing/2014/main" id="{CF57794D-40EB-4A2D-B774-87ABC38C5157}"/>
+                <a16:creationId xmlns:a16="http://schemas.microsoft.com/office/drawing/2014/main" id="{BC4DFBCC-1B88-45C8-992F-7D69A5CF047C}"/>
               </a:ext>
             </a:extLst>
           </p:cNvPr>
@@ -4598,7 +4566,7 @@
           <p:cNvPr id="23" name="">
             <a:extLst xmlns:a="http://schemas.openxmlformats.org/drawingml/2006/main">
               <a:ext uri="{FF2B5EF4-FFF2-40B4-BE49-F238E27FC236}">
-                <a16:creationId xmlns:a16="http://schemas.microsoft.com/office/drawing/2014/main" id="{7CFB4C25-D642-4086-A876-49A5C0C289AA}"/>
+                <a16:creationId xmlns:a16="http://schemas.microsoft.com/office/drawing/2014/main" id="{C50EAFE0-5DBB-4928-9D3B-50609B7ACDF7}"/>
               </a:ext>
             </a:extLst>
           </p:cNvPr>
@@ -4654,7 +4622,7 @@
           <p:cNvPr id="24" name="">
             <a:extLst xmlns:a="http://schemas.openxmlformats.org/drawingml/2006/main">
               <a:ext uri="{FF2B5EF4-FFF2-40B4-BE49-F238E27FC236}">
-                <a16:creationId xmlns:a16="http://schemas.microsoft.com/office/drawing/2014/main" id="{56B8ADE5-C208-47EB-A674-C6B0CB06B923}"/>
+                <a16:creationId xmlns:a16="http://schemas.microsoft.com/office/drawing/2014/main" id="{9931322D-9E4E-4089-B04A-6A98D4A28391}"/>
               </a:ext>
             </a:extLst>
           </p:cNvPr>
@@ -4687,7 +4655,7 @@
           <p:cNvPr id="25" name="">
             <a:extLst xmlns:a="http://schemas.openxmlformats.org/drawingml/2006/main">
               <a:ext uri="{FF2B5EF4-FFF2-40B4-BE49-F238E27FC236}">
-                <a16:creationId xmlns:a16="http://schemas.microsoft.com/office/drawing/2014/main" id="{1240D8C5-188D-4084-94A8-A1B355FD3ACE}"/>
+                <a16:creationId xmlns:a16="http://schemas.microsoft.com/office/drawing/2014/main" id="{68984EF2-ECE2-4E57-833F-B3662D9634F4}"/>
               </a:ext>
             </a:extLst>
           </p:cNvPr>
@@ -4743,7 +4711,7 @@
           <p:cNvPr id="26" name="">
             <a:extLst xmlns:a="http://schemas.openxmlformats.org/drawingml/2006/main">
               <a:ext uri="{FF2B5EF4-FFF2-40B4-BE49-F238E27FC236}">
-                <a16:creationId xmlns:a16="http://schemas.microsoft.com/office/drawing/2014/main" id="{17DF5F5A-A113-4A05-BC36-6EA80FA38B60}"/>
+                <a16:creationId xmlns:a16="http://schemas.microsoft.com/office/drawing/2014/main" id="{52D68243-5D41-417E-845F-1CFBDEB9EFD6}"/>
               </a:ext>
             </a:extLst>
           </p:cNvPr>
@@ -4774,7 +4742,7 @@
           <p:cNvPr id="27" name="">
             <a:extLst xmlns:a="http://schemas.openxmlformats.org/drawingml/2006/main">
               <a:ext uri="{FF2B5EF4-FFF2-40B4-BE49-F238E27FC236}">
-                <a16:creationId xmlns:a16="http://schemas.microsoft.com/office/drawing/2014/main" id="{DCDEF366-D40D-4F8F-AD01-410647C62604}"/>
+                <a16:creationId xmlns:a16="http://schemas.microsoft.com/office/drawing/2014/main" id="{DDFC89F9-4CAE-4259-BAAD-48ACCA82EB05}"/>
               </a:ext>
             </a:extLst>
           </p:cNvPr>
@@ -4830,7 +4798,7 @@
           <p:cNvPr id="28" name="">
             <a:extLst xmlns:a="http://schemas.openxmlformats.org/drawingml/2006/main">
               <a:ext uri="{FF2B5EF4-FFF2-40B4-BE49-F238E27FC236}">
-                <a16:creationId xmlns:a16="http://schemas.microsoft.com/office/drawing/2014/main" id="{3D57237D-8F92-40A6-84A4-5B3CEC4D60BD}"/>
+                <a16:creationId xmlns:a16="http://schemas.microsoft.com/office/drawing/2014/main" id="{577E27D1-F9D6-41BB-B97A-BCF2B6D53E35}"/>
               </a:ext>
             </a:extLst>
           </p:cNvPr>
@@ -4863,7 +4831,7 @@
           <p:cNvPr id="29" name="">
             <a:extLst xmlns:a="http://schemas.openxmlformats.org/drawingml/2006/main">
               <a:ext uri="{FF2B5EF4-FFF2-40B4-BE49-F238E27FC236}">
-                <a16:creationId xmlns:a16="http://schemas.microsoft.com/office/drawing/2014/main" id="{86251624-9C04-40FE-BDF2-EA56808E28B3}"/>
+                <a16:creationId xmlns:a16="http://schemas.microsoft.com/office/drawing/2014/main" id="{C4F4385A-5C97-4EDC-B23B-D735099D764E}"/>
               </a:ext>
             </a:extLst>
           </p:cNvPr>
@@ -4919,7 +4887,7 @@
           <p:cNvPr id="30" name="">
             <a:extLst xmlns:a="http://schemas.openxmlformats.org/drawingml/2006/main">
               <a:ext uri="{FF2B5EF4-FFF2-40B4-BE49-F238E27FC236}">
-                <a16:creationId xmlns:a16="http://schemas.microsoft.com/office/drawing/2014/main" id="{03DCA1C8-6878-40F3-9986-6B60B4EF0165}"/>
+                <a16:creationId xmlns:a16="http://schemas.microsoft.com/office/drawing/2014/main" id="{FEE9E4E1-51F3-462A-8F64-B1A9E0184D21}"/>
               </a:ext>
             </a:extLst>
           </p:cNvPr>
@@ -4950,7 +4918,7 @@
           <p:cNvPr id="31" name="">
             <a:extLst xmlns:a="http://schemas.openxmlformats.org/drawingml/2006/main">
               <a:ext uri="{FF2B5EF4-FFF2-40B4-BE49-F238E27FC236}">
-                <a16:creationId xmlns:a16="http://schemas.microsoft.com/office/drawing/2014/main" id="{03F0A22A-F172-4A15-BE4E-DB6D9A8D584E}"/>
+                <a16:creationId xmlns:a16="http://schemas.microsoft.com/office/drawing/2014/main" id="{01143ACC-A37E-4D9A-B644-4916520B5513}"/>
               </a:ext>
             </a:extLst>
           </p:cNvPr>
@@ -5006,7 +4974,7 @@
           <p:cNvPr id="32" name="">
             <a:extLst xmlns:a="http://schemas.openxmlformats.org/drawingml/2006/main">
               <a:ext uri="{FF2B5EF4-FFF2-40B4-BE49-F238E27FC236}">
-                <a16:creationId xmlns:a16="http://schemas.microsoft.com/office/drawing/2014/main" id="{A91EBEA5-CA21-4914-A2EA-3FFE55D3D201}"/>
+                <a16:creationId xmlns:a16="http://schemas.microsoft.com/office/drawing/2014/main" id="{05340E29-99A6-4189-A0B4-5617736699FB}"/>
               </a:ext>
             </a:extLst>
           </p:cNvPr>
@@ -5037,7 +5005,7 @@
           <p:cNvPr id="33" name="">
             <a:extLst xmlns:a="http://schemas.openxmlformats.org/drawingml/2006/main">
               <a:ext uri="{FF2B5EF4-FFF2-40B4-BE49-F238E27FC236}">
-                <a16:creationId xmlns:a16="http://schemas.microsoft.com/office/drawing/2014/main" id="{62BFDC76-91BF-4FBF-9284-FF684110C15D}"/>
+                <a16:creationId xmlns:a16="http://schemas.microsoft.com/office/drawing/2014/main" id="{F6797928-604C-45CC-B4C3-483AC47188A7}"/>
               </a:ext>
             </a:extLst>
           </p:cNvPr>
@@ -5093,7 +5061,7 @@
           <p:cNvPr id="34" name="">
             <a:extLst xmlns:a="http://schemas.openxmlformats.org/drawingml/2006/main">
               <a:ext uri="{FF2B5EF4-FFF2-40B4-BE49-F238E27FC236}">
-                <a16:creationId xmlns:a16="http://schemas.microsoft.com/office/drawing/2014/main" id="{06B057FD-BF91-4F31-9966-D49145D53AA3}"/>
+                <a16:creationId xmlns:a16="http://schemas.microsoft.com/office/drawing/2014/main" id="{FD88C46F-F748-4FF2-B089-82234AD154B7}"/>
               </a:ext>
             </a:extLst>
           </p:cNvPr>
@@ -5149,7 +5117,7 @@
           <p:cNvPr id="35" name="">
             <a:extLst xmlns:a="http://schemas.openxmlformats.org/drawingml/2006/main">
               <a:ext uri="{FF2B5EF4-FFF2-40B4-BE49-F238E27FC236}">
-                <a16:creationId xmlns:a16="http://schemas.microsoft.com/office/drawing/2014/main" id="{5CAE2829-8694-438F-A7EC-D7EFB5E0DA6D}"/>
+                <a16:creationId xmlns:a16="http://schemas.microsoft.com/office/drawing/2014/main" id="{2A8BE7E1-CDF8-45E7-B10E-A0C2DDD85FD5}"/>
               </a:ext>
             </a:extLst>
           </p:cNvPr>
@@ -5180,7 +5148,7 @@
           <p:cNvPr id="36" name="">
             <a:extLst xmlns:a="http://schemas.openxmlformats.org/drawingml/2006/main">
               <a:ext uri="{FF2B5EF4-FFF2-40B4-BE49-F238E27FC236}">
-                <a16:creationId xmlns:a16="http://schemas.microsoft.com/office/drawing/2014/main" id="{A0F72175-CA59-4F36-A9E5-87B3EE1456E7}"/>
+                <a16:creationId xmlns:a16="http://schemas.microsoft.com/office/drawing/2014/main" id="{C29BE7CD-7DDF-4141-B26A-CD0FBF877563}"/>
               </a:ext>
             </a:extLst>
           </p:cNvPr>
@@ -5236,7 +5204,7 @@
           <p:cNvPr id="37" name="">
             <a:extLst xmlns:a="http://schemas.openxmlformats.org/drawingml/2006/main">
               <a:ext uri="{FF2B5EF4-FFF2-40B4-BE49-F238E27FC236}">
-                <a16:creationId xmlns:a16="http://schemas.microsoft.com/office/drawing/2014/main" id="{13655992-32D3-4E9B-A0E1-00744DE3C031}"/>
+                <a16:creationId xmlns:a16="http://schemas.microsoft.com/office/drawing/2014/main" id="{D86CA8F8-1AB5-4A3F-A7CE-DBDFAEE27C9B}"/>
               </a:ext>
             </a:extLst>
           </p:cNvPr>
@@ -5292,7 +5260,7 @@
           <p:cNvPr id="38" name="">
             <a:extLst xmlns:a="http://schemas.openxmlformats.org/drawingml/2006/main">
               <a:ext uri="{FF2B5EF4-FFF2-40B4-BE49-F238E27FC236}">
-                <a16:creationId xmlns:a16="http://schemas.microsoft.com/office/drawing/2014/main" id="{1385345B-83FB-40C2-973C-04B8FC0A93D6}"/>
+                <a16:creationId xmlns:a16="http://schemas.microsoft.com/office/drawing/2014/main" id="{14E0D2EF-52F9-4F58-BECA-5AE6B9130029}"/>
               </a:ext>
             </a:extLst>
           </p:cNvPr>
@@ -5323,7 +5291,7 @@
           <p:cNvPr id="39" name="">
             <a:extLst xmlns:a="http://schemas.openxmlformats.org/drawingml/2006/main">
               <a:ext uri="{FF2B5EF4-FFF2-40B4-BE49-F238E27FC236}">
-                <a16:creationId xmlns:a16="http://schemas.microsoft.com/office/drawing/2014/main" id="{A619D874-0529-4725-87FE-04180D1C6432}"/>
+                <a16:creationId xmlns:a16="http://schemas.microsoft.com/office/drawing/2014/main" id="{D13A891A-8C49-494F-B0D8-80A9F28F0D82}"/>
               </a:ext>
             </a:extLst>
           </p:cNvPr>
@@ -5379,7 +5347,7 @@
           <p:cNvPr id="40" name="">
             <a:extLst xmlns:a="http://schemas.openxmlformats.org/drawingml/2006/main">
               <a:ext uri="{FF2B5EF4-FFF2-40B4-BE49-F238E27FC236}">
-                <a16:creationId xmlns:a16="http://schemas.microsoft.com/office/drawing/2014/main" id="{5AF74220-F523-41C5-9F39-B52291EF3AE4}"/>
+                <a16:creationId xmlns:a16="http://schemas.microsoft.com/office/drawing/2014/main" id="{8C06F8CC-530B-4F1E-AB5D-BB7AA36FF8E8}"/>
               </a:ext>
             </a:extLst>
           </p:cNvPr>
@@ -5433,7 +5401,7 @@
     </p:spTree>
     <p:extLst>
       <p:ext uri="{BB962C8B-B14F-4D97-AF65-F5344CB8AC3E}">
-        <p14:creationId xmlns:p14="http://schemas.microsoft.com/office/powerpoint/2010/main" val="875687527"/>
+        <p14:creationId xmlns:p14="http://schemas.microsoft.com/office/powerpoint/2010/main" val="1867551355"/>
       </p:ext>
     </p:extLst>
   </p:cSld>
@@ -5464,7 +5432,7 @@
           <p:cNvPr id="1" name="">
             <a:extLst xmlns:a="http://schemas.openxmlformats.org/drawingml/2006/main">
               <a:ext uri="{FF2B5EF4-FFF2-40B4-BE49-F238E27FC236}">
-                <a16:creationId xmlns:a16="http://schemas.microsoft.com/office/drawing/2014/main" id="{F6D7F8D3-0C69-48D8-B6A9-9BB41F44C853}"/>
+                <a16:creationId xmlns:a16="http://schemas.microsoft.com/office/drawing/2014/main" id="{ACBA1DCC-8A7A-4C8F-BECD-CED5DD7C4122}"/>
               </a:ext>
             </a:extLst>
           </p:cNvPr>
@@ -5520,7 +5488,7 @@
           <p:cNvPr id="2" name="">
             <a:extLst xmlns:a="http://schemas.openxmlformats.org/drawingml/2006/main">
               <a:ext uri="{FF2B5EF4-FFF2-40B4-BE49-F238E27FC236}">
-                <a16:creationId xmlns:a16="http://schemas.microsoft.com/office/drawing/2014/main" id="{A2AF9016-06AE-4C4E-BCDC-5440751B8FB2}"/>
+                <a16:creationId xmlns:a16="http://schemas.microsoft.com/office/drawing/2014/main" id="{315981B4-6359-4B65-8298-79CB634D5D2B}"/>
               </a:ext>
             </a:extLst>
           </p:cNvPr>
@@ -5551,7 +5519,7 @@
           <p:cNvPr id="3" name="">
             <a:extLst xmlns:a="http://schemas.openxmlformats.org/drawingml/2006/main">
               <a:ext uri="{FF2B5EF4-FFF2-40B4-BE49-F238E27FC236}">
-                <a16:creationId xmlns:a16="http://schemas.microsoft.com/office/drawing/2014/main" id="{929B70A8-DC4F-4EEC-B0BA-F79B2403FA94}"/>
+                <a16:creationId xmlns:a16="http://schemas.microsoft.com/office/drawing/2014/main" id="{A1C17F6E-72AB-48BF-BA4C-2282EF89190F}"/>
               </a:ext>
             </a:extLst>
           </p:cNvPr>
@@ -5607,7 +5575,7 @@
           <p:cNvPr id="4" name="">
             <a:extLst xmlns:a="http://schemas.openxmlformats.org/drawingml/2006/main">
               <a:ext uri="{FF2B5EF4-FFF2-40B4-BE49-F238E27FC236}">
-                <a16:creationId xmlns:a16="http://schemas.microsoft.com/office/drawing/2014/main" id="{D5E36FE7-6A71-49C4-BB87-0E17F19AF47D}"/>
+                <a16:creationId xmlns:a16="http://schemas.microsoft.com/office/drawing/2014/main" id="{4AA697FE-25A9-4CD6-B95B-1341C40B829B}"/>
               </a:ext>
             </a:extLst>
           </p:cNvPr>
@@ -5638,7 +5606,7 @@
           <p:cNvPr id="5" name="">
             <a:extLst xmlns:a="http://schemas.openxmlformats.org/drawingml/2006/main">
               <a:ext uri="{FF2B5EF4-FFF2-40B4-BE49-F238E27FC236}">
-                <a16:creationId xmlns:a16="http://schemas.microsoft.com/office/drawing/2014/main" id="{86A43098-49BE-45BD-A91F-05090E5328A0}"/>
+                <a16:creationId xmlns:a16="http://schemas.microsoft.com/office/drawing/2014/main" id="{88AECB72-0AF7-4E95-921F-6272AD9B47DA}"/>
               </a:ext>
             </a:extLst>
           </p:cNvPr>
@@ -5694,7 +5662,7 @@
           <p:cNvPr id="6" name="">
             <a:extLst xmlns:a="http://schemas.openxmlformats.org/drawingml/2006/main">
               <a:ext uri="{FF2B5EF4-FFF2-40B4-BE49-F238E27FC236}">
-                <a16:creationId xmlns:a16="http://schemas.microsoft.com/office/drawing/2014/main" id="{E63ECC54-20CB-42E2-93E5-B401B8A23B13}"/>
+                <a16:creationId xmlns:a16="http://schemas.microsoft.com/office/drawing/2014/main" id="{81DF3065-8E8E-4939-86CC-FA1A3F3D79FB}"/>
               </a:ext>
             </a:extLst>
           </p:cNvPr>
@@ -5725,7 +5693,7 @@
           <p:cNvPr id="7" name="">
             <a:extLst xmlns:a="http://schemas.openxmlformats.org/drawingml/2006/main">
               <a:ext uri="{FF2B5EF4-FFF2-40B4-BE49-F238E27FC236}">
-                <a16:creationId xmlns:a16="http://schemas.microsoft.com/office/drawing/2014/main" id="{AEC9AED2-FBE1-4C2A-B881-8E08960A878F}"/>
+                <a16:creationId xmlns:a16="http://schemas.microsoft.com/office/drawing/2014/main" id="{B6F3E117-4046-402E-83B1-EE8158E4721D}"/>
               </a:ext>
             </a:extLst>
           </p:cNvPr>
@@ -5781,7 +5749,7 @@
           <p:cNvPr id="8" name="">
             <a:extLst xmlns:a="http://schemas.openxmlformats.org/drawingml/2006/main">
               <a:ext uri="{FF2B5EF4-FFF2-40B4-BE49-F238E27FC236}">
-                <a16:creationId xmlns:a16="http://schemas.microsoft.com/office/drawing/2014/main" id="{AE691823-DCDD-4160-86BC-4E4AC919DD73}"/>
+                <a16:creationId xmlns:a16="http://schemas.microsoft.com/office/drawing/2014/main" id="{452833F4-69D5-438A-A5CF-856BB1212797}"/>
               </a:ext>
             </a:extLst>
           </p:cNvPr>
@@ -5812,7 +5780,7 @@
           <p:cNvPr id="9" name="">
             <a:extLst xmlns:a="http://schemas.openxmlformats.org/drawingml/2006/main">
               <a:ext uri="{FF2B5EF4-FFF2-40B4-BE49-F238E27FC236}">
-                <a16:creationId xmlns:a16="http://schemas.microsoft.com/office/drawing/2014/main" id="{649ABFD2-CCB9-413B-8C85-6E03523BE7C2}"/>
+                <a16:creationId xmlns:a16="http://schemas.microsoft.com/office/drawing/2014/main" id="{F6C3E2D5-5B8E-4E4C-8015-825CEB2C9795}"/>
               </a:ext>
             </a:extLst>
           </p:cNvPr>
@@ -5868,7 +5836,7 @@
           <p:cNvPr id="10" name="">
             <a:extLst xmlns:a="http://schemas.openxmlformats.org/drawingml/2006/main">
               <a:ext uri="{FF2B5EF4-FFF2-40B4-BE49-F238E27FC236}">
-                <a16:creationId xmlns:a16="http://schemas.microsoft.com/office/drawing/2014/main" id="{0EC63C08-BAED-4AAA-BD9B-B44B70754A85}"/>
+                <a16:creationId xmlns:a16="http://schemas.microsoft.com/office/drawing/2014/main" id="{47F4C69A-A92A-48CE-B916-43525473A9EB}"/>
               </a:ext>
             </a:extLst>
           </p:cNvPr>
@@ -5899,7 +5867,7 @@
           <p:cNvPr id="11" name="">
             <a:extLst xmlns:a="http://schemas.openxmlformats.org/drawingml/2006/main">
               <a:ext uri="{FF2B5EF4-FFF2-40B4-BE49-F238E27FC236}">
-                <a16:creationId xmlns:a16="http://schemas.microsoft.com/office/drawing/2014/main" id="{97DEC668-F4B8-4BBB-8EC6-F95BFAD5AB95}"/>
+                <a16:creationId xmlns:a16="http://schemas.microsoft.com/office/drawing/2014/main" id="{7F03FD30-5D40-4F5A-BA5D-04403952008E}"/>
               </a:ext>
             </a:extLst>
           </p:cNvPr>
@@ -5955,7 +5923,7 @@
           <p:cNvPr id="12" name="">
             <a:extLst xmlns:a="http://schemas.openxmlformats.org/drawingml/2006/main">
               <a:ext uri="{FF2B5EF4-FFF2-40B4-BE49-F238E27FC236}">
-                <a16:creationId xmlns:a16="http://schemas.microsoft.com/office/drawing/2014/main" id="{C2823A0B-608E-4F05-8AFF-48A88EE8A008}"/>
+                <a16:creationId xmlns:a16="http://schemas.microsoft.com/office/drawing/2014/main" id="{B661D1D2-BEB6-42B5-816F-5FD8E1AD88D9}"/>
               </a:ext>
             </a:extLst>
           </p:cNvPr>
@@ -5986,7 +5954,7 @@
           <p:cNvPr id="13" name="">
             <a:extLst xmlns:a="http://schemas.openxmlformats.org/drawingml/2006/main">
               <a:ext uri="{FF2B5EF4-FFF2-40B4-BE49-F238E27FC236}">
-                <a16:creationId xmlns:a16="http://schemas.microsoft.com/office/drawing/2014/main" id="{BE2EE688-76E6-4743-90CF-FD881F6C8D10}"/>
+                <a16:creationId xmlns:a16="http://schemas.microsoft.com/office/drawing/2014/main" id="{80FEB335-F750-40FC-97A8-D0FCCBBC3B5E}"/>
               </a:ext>
             </a:extLst>
           </p:cNvPr>
@@ -6042,7 +6010,7 @@
           <p:cNvPr id="14" name="">
             <a:extLst xmlns:a="http://schemas.openxmlformats.org/drawingml/2006/main">
               <a:ext uri="{FF2B5EF4-FFF2-40B4-BE49-F238E27FC236}">
-                <a16:creationId xmlns:a16="http://schemas.microsoft.com/office/drawing/2014/main" id="{1979FD13-FB96-4DA9-9916-8495F16D34DD}"/>
+                <a16:creationId xmlns:a16="http://schemas.microsoft.com/office/drawing/2014/main" id="{04A4965A-4F94-4FD7-897E-F5AE38235A99}"/>
               </a:ext>
             </a:extLst>
           </p:cNvPr>
@@ -6098,7 +6066,7 @@
           <p:cNvPr id="15" name="">
             <a:extLst xmlns:a="http://schemas.openxmlformats.org/drawingml/2006/main">
               <a:ext uri="{FF2B5EF4-FFF2-40B4-BE49-F238E27FC236}">
-                <a16:creationId xmlns:a16="http://schemas.microsoft.com/office/drawing/2014/main" id="{7DD2DA22-78E2-4D7E-BF1A-C0B25B678404}"/>
+                <a16:creationId xmlns:a16="http://schemas.microsoft.com/office/drawing/2014/main" id="{95D7AAFA-FDB1-4C7B-B46F-819252832B5E}"/>
               </a:ext>
             </a:extLst>
           </p:cNvPr>
@@ -6129,7 +6097,7 @@
           <p:cNvPr id="16" name="">
             <a:extLst xmlns:a="http://schemas.openxmlformats.org/drawingml/2006/main">
               <a:ext uri="{FF2B5EF4-FFF2-40B4-BE49-F238E27FC236}">
-                <a16:creationId xmlns:a16="http://schemas.microsoft.com/office/drawing/2014/main" id="{DB3E3941-5D62-4A26-A3A2-4E6675ADAAF8}"/>
+                <a16:creationId xmlns:a16="http://schemas.microsoft.com/office/drawing/2014/main" id="{F2AEE81B-DB30-4015-8FFB-B20275C7AA9E}"/>
               </a:ext>
             </a:extLst>
           </p:cNvPr>
@@ -6185,7 +6153,7 @@
           <p:cNvPr id="17" name="">
             <a:extLst xmlns:a="http://schemas.openxmlformats.org/drawingml/2006/main">
               <a:ext uri="{FF2B5EF4-FFF2-40B4-BE49-F238E27FC236}">
-                <a16:creationId xmlns:a16="http://schemas.microsoft.com/office/drawing/2014/main" id="{4C0F9416-0449-4707-8202-E6FC56441237}"/>
+                <a16:creationId xmlns:a16="http://schemas.microsoft.com/office/drawing/2014/main" id="{1CF1A540-29BA-44FE-A72C-ACEEF1891C90}"/>
               </a:ext>
             </a:extLst>
           </p:cNvPr>
@@ -6241,7 +6209,7 @@
           <p:cNvPr id="18" name="">
             <a:extLst xmlns:a="http://schemas.openxmlformats.org/drawingml/2006/main">
               <a:ext uri="{FF2B5EF4-FFF2-40B4-BE49-F238E27FC236}">
-                <a16:creationId xmlns:a16="http://schemas.microsoft.com/office/drawing/2014/main" id="{C026EF78-E74A-4CE0-8C83-3C12CD984186}"/>
+                <a16:creationId xmlns:a16="http://schemas.microsoft.com/office/drawing/2014/main" id="{C41095E4-071B-4DF0-AABA-332FB30414CB}"/>
               </a:ext>
             </a:extLst>
           </p:cNvPr>
@@ -6272,7 +6240,7 @@
           <p:cNvPr id="19" name="">
             <a:extLst xmlns:a="http://schemas.openxmlformats.org/drawingml/2006/main">
               <a:ext uri="{FF2B5EF4-FFF2-40B4-BE49-F238E27FC236}">
-                <a16:creationId xmlns:a16="http://schemas.microsoft.com/office/drawing/2014/main" id="{D95BABA8-28F3-4786-90C6-D26D71BF46EF}"/>
+                <a16:creationId xmlns:a16="http://schemas.microsoft.com/office/drawing/2014/main" id="{F8938CAB-962C-4151-8692-943A095A31D2}"/>
               </a:ext>
             </a:extLst>
           </p:cNvPr>
@@ -6328,7 +6296,7 @@
           <p:cNvPr id="20" name="">
             <a:extLst xmlns:a="http://schemas.openxmlformats.org/drawingml/2006/main">
               <a:ext uri="{FF2B5EF4-FFF2-40B4-BE49-F238E27FC236}">
-                <a16:creationId xmlns:a16="http://schemas.microsoft.com/office/drawing/2014/main" id="{930555AF-878B-422B-AEDC-1E3CF53FF121}"/>
+                <a16:creationId xmlns:a16="http://schemas.microsoft.com/office/drawing/2014/main" id="{4CA9F9C5-2F5C-4DD8-8FE0-AAEFFC8FAAB2}"/>
               </a:ext>
             </a:extLst>
           </p:cNvPr>
@@ -6384,7 +6352,7 @@
           <p:cNvPr id="21" name="">
             <a:extLst xmlns:a="http://schemas.openxmlformats.org/drawingml/2006/main">
               <a:ext uri="{FF2B5EF4-FFF2-40B4-BE49-F238E27FC236}">
-                <a16:creationId xmlns:a16="http://schemas.microsoft.com/office/drawing/2014/main" id="{0A15107E-276F-4E52-890F-44190CF6DEC5}"/>
+                <a16:creationId xmlns:a16="http://schemas.microsoft.com/office/drawing/2014/main" id="{AED8615E-0F80-4419-8239-7260EB81089E}"/>
               </a:ext>
             </a:extLst>
           </p:cNvPr>
@@ -6415,7 +6383,7 @@
           <p:cNvPr id="22" name="">
             <a:extLst xmlns:a="http://schemas.openxmlformats.org/drawingml/2006/main">
               <a:ext uri="{FF2B5EF4-FFF2-40B4-BE49-F238E27FC236}">
-                <a16:creationId xmlns:a16="http://schemas.microsoft.com/office/drawing/2014/main" id="{1020DB7B-E758-49E0-9732-A329F38BE0F3}"/>
+                <a16:creationId xmlns:a16="http://schemas.microsoft.com/office/drawing/2014/main" id="{B524579A-F9B0-4649-99C1-2AEACDD55B36}"/>
               </a:ext>
             </a:extLst>
           </p:cNvPr>
@@ -6471,7 +6439,7 @@
           <p:cNvPr id="23" name="">
             <a:extLst xmlns:a="http://schemas.openxmlformats.org/drawingml/2006/main">
               <a:ext uri="{FF2B5EF4-FFF2-40B4-BE49-F238E27FC236}">
-                <a16:creationId xmlns:a16="http://schemas.microsoft.com/office/drawing/2014/main" id="{D04C94A8-D373-4064-8DC4-17E82FA1AC79}"/>
+                <a16:creationId xmlns:a16="http://schemas.microsoft.com/office/drawing/2014/main" id="{303415B3-92CB-457B-8080-EC0E81CC4D45}"/>
               </a:ext>
             </a:extLst>
           </p:cNvPr>
@@ -6525,7 +6493,7 @@
     </p:spTree>
     <p:extLst>
       <p:ext uri="{BB962C8B-B14F-4D97-AF65-F5344CB8AC3E}">
-        <p14:creationId xmlns:p14="http://schemas.microsoft.com/office/powerpoint/2010/main" val="418908075"/>
+        <p14:creationId xmlns:p14="http://schemas.microsoft.com/office/powerpoint/2010/main" val="899191632"/>
       </p:ext>
     </p:extLst>
   </p:cSld>
@@ -6556,7 +6524,7 @@
           <p:cNvPr id="1" name="">
             <a:extLst xmlns:a="http://schemas.openxmlformats.org/drawingml/2006/main">
               <a:ext uri="{FF2B5EF4-FFF2-40B4-BE49-F238E27FC236}">
-                <a16:creationId xmlns:a16="http://schemas.microsoft.com/office/drawing/2014/main" id="{7B7638E9-DCAB-4954-9759-DC05B0962B42}"/>
+                <a16:creationId xmlns:a16="http://schemas.microsoft.com/office/drawing/2014/main" id="{750547AD-5E0B-4951-A738-01A91B842824}"/>
               </a:ext>
             </a:extLst>
           </p:cNvPr>
@@ -6612,7 +6580,7 @@
           <p:cNvPr id="2" name="">
             <a:extLst xmlns:a="http://schemas.openxmlformats.org/drawingml/2006/main">
               <a:ext uri="{FF2B5EF4-FFF2-40B4-BE49-F238E27FC236}">
-                <a16:creationId xmlns:a16="http://schemas.microsoft.com/office/drawing/2014/main" id="{FA582FB3-E609-415B-876B-D23276E2188F}"/>
+                <a16:creationId xmlns:a16="http://schemas.microsoft.com/office/drawing/2014/main" id="{68E3C179-67B6-4106-91F1-5A6182FC209C}"/>
               </a:ext>
             </a:extLst>
           </p:cNvPr>
@@ -6643,7 +6611,7 @@
           <p:cNvPr id="3" name="">
             <a:extLst xmlns:a="http://schemas.openxmlformats.org/drawingml/2006/main">
               <a:ext uri="{FF2B5EF4-FFF2-40B4-BE49-F238E27FC236}">
-                <a16:creationId xmlns:a16="http://schemas.microsoft.com/office/drawing/2014/main" id="{6621B2A0-C8AD-449B-AFBC-CB3A6DD0AA52}"/>
+                <a16:creationId xmlns:a16="http://schemas.microsoft.com/office/drawing/2014/main" id="{E0419572-6962-4DFA-BC08-7D7814539B7E}"/>
               </a:ext>
             </a:extLst>
           </p:cNvPr>
@@ -6699,7 +6667,7 @@
           <p:cNvPr id="4" name="">
             <a:extLst xmlns:a="http://schemas.openxmlformats.org/drawingml/2006/main">
               <a:ext uri="{FF2B5EF4-FFF2-40B4-BE49-F238E27FC236}">
-                <a16:creationId xmlns:a16="http://schemas.microsoft.com/office/drawing/2014/main" id="{BAA2065D-503F-4C84-9E04-457EC319E16E}"/>
+                <a16:creationId xmlns:a16="http://schemas.microsoft.com/office/drawing/2014/main" id="{70C9573C-8980-4FBE-8B6B-6F6258DA08A4}"/>
               </a:ext>
             </a:extLst>
           </p:cNvPr>
@@ -6732,7 +6700,7 @@
           <p:cNvPr id="5" name="">
             <a:extLst xmlns:a="http://schemas.openxmlformats.org/drawingml/2006/main">
               <a:ext uri="{FF2B5EF4-FFF2-40B4-BE49-F238E27FC236}">
-                <a16:creationId xmlns:a16="http://schemas.microsoft.com/office/drawing/2014/main" id="{97DC021F-6658-43C6-B84B-E297A63A331D}"/>
+                <a16:creationId xmlns:a16="http://schemas.microsoft.com/office/drawing/2014/main" id="{0214407B-E27D-44A5-87C5-2EBF2CAA16CF}"/>
               </a:ext>
             </a:extLst>
           </p:cNvPr>
@@ -6788,7 +6756,7 @@
           <p:cNvPr id="6" name="">
             <a:extLst xmlns:a="http://schemas.openxmlformats.org/drawingml/2006/main">
               <a:ext uri="{FF2B5EF4-FFF2-40B4-BE49-F238E27FC236}">
-                <a16:creationId xmlns:a16="http://schemas.microsoft.com/office/drawing/2014/main" id="{41DF194A-B885-455B-805A-0FF6F18236E4}"/>
+                <a16:creationId xmlns:a16="http://schemas.microsoft.com/office/drawing/2014/main" id="{BD78757A-8C3A-4C77-9E2E-3BE8D5F273A3}"/>
               </a:ext>
             </a:extLst>
           </p:cNvPr>
@@ -6819,7 +6787,7 @@
           <p:cNvPr id="7" name="">
             <a:extLst xmlns:a="http://schemas.openxmlformats.org/drawingml/2006/main">
               <a:ext uri="{FF2B5EF4-FFF2-40B4-BE49-F238E27FC236}">
-                <a16:creationId xmlns:a16="http://schemas.microsoft.com/office/drawing/2014/main" id="{BBE59844-46E8-402D-BB44-20991C436346}"/>
+                <a16:creationId xmlns:a16="http://schemas.microsoft.com/office/drawing/2014/main" id="{DEDA0931-A763-4B4B-91E8-E18AA4EB8AC3}"/>
               </a:ext>
             </a:extLst>
           </p:cNvPr>
@@ -6875,7 +6843,7 @@
           <p:cNvPr id="8" name="">
             <a:extLst xmlns:a="http://schemas.openxmlformats.org/drawingml/2006/main">
               <a:ext uri="{FF2B5EF4-FFF2-40B4-BE49-F238E27FC236}">
-                <a16:creationId xmlns:a16="http://schemas.microsoft.com/office/drawing/2014/main" id="{FBA425D9-D849-49A3-8178-6A00EC3E8C99}"/>
+                <a16:creationId xmlns:a16="http://schemas.microsoft.com/office/drawing/2014/main" id="{6B1FC78D-39F9-4015-8AA7-7553944F2DEA}"/>
               </a:ext>
             </a:extLst>
           </p:cNvPr>
@@ -6906,7 +6874,7 @@
           <p:cNvPr id="9" name="">
             <a:extLst xmlns:a="http://schemas.openxmlformats.org/drawingml/2006/main">
               <a:ext uri="{FF2B5EF4-FFF2-40B4-BE49-F238E27FC236}">
-                <a16:creationId xmlns:a16="http://schemas.microsoft.com/office/drawing/2014/main" id="{C3204206-D7E5-4EA1-80D2-5F11ABE82845}"/>
+                <a16:creationId xmlns:a16="http://schemas.microsoft.com/office/drawing/2014/main" id="{F045B006-18E8-4BC7-8EDC-2F8A78DCC5BB}"/>
               </a:ext>
             </a:extLst>
           </p:cNvPr>
@@ -6962,7 +6930,7 @@
           <p:cNvPr id="10" name="">
             <a:extLst xmlns:a="http://schemas.openxmlformats.org/drawingml/2006/main">
               <a:ext uri="{FF2B5EF4-FFF2-40B4-BE49-F238E27FC236}">
-                <a16:creationId xmlns:a16="http://schemas.microsoft.com/office/drawing/2014/main" id="{FCB109A9-8F90-4EDE-82D7-C255BFB03314}"/>
+                <a16:creationId xmlns:a16="http://schemas.microsoft.com/office/drawing/2014/main" id="{BD70A505-DB57-421A-B37C-6E67896D9641}"/>
               </a:ext>
             </a:extLst>
           </p:cNvPr>
@@ -6993,7 +6961,7 @@
           <p:cNvPr id="11" name="">
             <a:extLst xmlns:a="http://schemas.openxmlformats.org/drawingml/2006/main">
               <a:ext uri="{FF2B5EF4-FFF2-40B4-BE49-F238E27FC236}">
-                <a16:creationId xmlns:a16="http://schemas.microsoft.com/office/drawing/2014/main" id="{3E5F96D5-DFBC-46FF-8840-21880E48BC4C}"/>
+                <a16:creationId xmlns:a16="http://schemas.microsoft.com/office/drawing/2014/main" id="{43E63DF2-AFA0-4F9C-BF50-B3496E393CAE}"/>
               </a:ext>
             </a:extLst>
           </p:cNvPr>
@@ -7049,7 +7017,7 @@
           <p:cNvPr id="12" name="">
             <a:extLst xmlns:a="http://schemas.openxmlformats.org/drawingml/2006/main">
               <a:ext uri="{FF2B5EF4-FFF2-40B4-BE49-F238E27FC236}">
-                <a16:creationId xmlns:a16="http://schemas.microsoft.com/office/drawing/2014/main" id="{7D534596-BBE1-47EC-9BFD-6EE260CDCFC3}"/>
+                <a16:creationId xmlns:a16="http://schemas.microsoft.com/office/drawing/2014/main" id="{6860D8C7-C729-4E4E-835F-96C2BF665657}"/>
               </a:ext>
             </a:extLst>
           </p:cNvPr>
@@ -7080,7 +7048,7 @@
           <p:cNvPr id="13" name="">
             <a:extLst xmlns:a="http://schemas.openxmlformats.org/drawingml/2006/main">
               <a:ext uri="{FF2B5EF4-FFF2-40B4-BE49-F238E27FC236}">
-                <a16:creationId xmlns:a16="http://schemas.microsoft.com/office/drawing/2014/main" id="{EB5706CE-0F9B-40F6-B30B-19CCB4F4335A}"/>
+                <a16:creationId xmlns:a16="http://schemas.microsoft.com/office/drawing/2014/main" id="{43913D9B-4DBB-4C2D-AA53-CA94225C5441}"/>
               </a:ext>
             </a:extLst>
           </p:cNvPr>
@@ -7136,7 +7104,7 @@
           <p:cNvPr id="14" name="">
             <a:extLst xmlns:a="http://schemas.openxmlformats.org/drawingml/2006/main">
               <a:ext uri="{FF2B5EF4-FFF2-40B4-BE49-F238E27FC236}">
-                <a16:creationId xmlns:a16="http://schemas.microsoft.com/office/drawing/2014/main" id="{A5DA5AAF-DFC5-478A-810D-FDE88210380B}"/>
+                <a16:creationId xmlns:a16="http://schemas.microsoft.com/office/drawing/2014/main" id="{A65B459C-6B31-494B-ACF1-8B0C41399F37}"/>
               </a:ext>
             </a:extLst>
           </p:cNvPr>
@@ -7167,7 +7135,7 @@
           <p:cNvPr id="15" name="">
             <a:extLst xmlns:a="http://schemas.openxmlformats.org/drawingml/2006/main">
               <a:ext uri="{FF2B5EF4-FFF2-40B4-BE49-F238E27FC236}">
-                <a16:creationId xmlns:a16="http://schemas.microsoft.com/office/drawing/2014/main" id="{983EDF4A-1D94-4B0E-8A8C-4396E8622FB9}"/>
+                <a16:creationId xmlns:a16="http://schemas.microsoft.com/office/drawing/2014/main" id="{4AE2FC5D-51F9-47FE-ADDE-7EFC2DE1CE96}"/>
               </a:ext>
             </a:extLst>
           </p:cNvPr>
@@ -7223,7 +7191,7 @@
           <p:cNvPr id="16" name="">
             <a:extLst xmlns:a="http://schemas.openxmlformats.org/drawingml/2006/main">
               <a:ext uri="{FF2B5EF4-FFF2-40B4-BE49-F238E27FC236}">
-                <a16:creationId xmlns:a16="http://schemas.microsoft.com/office/drawing/2014/main" id="{048F1FDF-8FBA-476C-A438-6AED69762FF5}"/>
+                <a16:creationId xmlns:a16="http://schemas.microsoft.com/office/drawing/2014/main" id="{C8415D6E-C1F5-4B01-AE6B-455C4CFBFD1C}"/>
               </a:ext>
             </a:extLst>
           </p:cNvPr>
@@ -7254,7 +7222,7 @@
           <p:cNvPr id="17" name="">
             <a:extLst xmlns:a="http://schemas.openxmlformats.org/drawingml/2006/main">
               <a:ext uri="{FF2B5EF4-FFF2-40B4-BE49-F238E27FC236}">
-                <a16:creationId xmlns:a16="http://schemas.microsoft.com/office/drawing/2014/main" id="{00A37C6A-ABA0-48A7-9C2E-133EF3156902}"/>
+                <a16:creationId xmlns:a16="http://schemas.microsoft.com/office/drawing/2014/main" id="{3B435170-02DC-4BD2-B9E2-10FB56FE4528}"/>
               </a:ext>
             </a:extLst>
           </p:cNvPr>
@@ -7310,7 +7278,7 @@
           <p:cNvPr id="18" name="">
             <a:extLst xmlns:a="http://schemas.openxmlformats.org/drawingml/2006/main">
               <a:ext uri="{FF2B5EF4-FFF2-40B4-BE49-F238E27FC236}">
-                <a16:creationId xmlns:a16="http://schemas.microsoft.com/office/drawing/2014/main" id="{74343965-76E0-43D1-8E8C-C212318F800F}"/>
+                <a16:creationId xmlns:a16="http://schemas.microsoft.com/office/drawing/2014/main" id="{FD70C83A-4F1D-417A-83E6-768A468D992D}"/>
               </a:ext>
             </a:extLst>
           </p:cNvPr>
@@ -7343,7 +7311,7 @@
           <p:cNvPr id="19" name="">
             <a:extLst xmlns:a="http://schemas.openxmlformats.org/drawingml/2006/main">
               <a:ext uri="{FF2B5EF4-FFF2-40B4-BE49-F238E27FC236}">
-                <a16:creationId xmlns:a16="http://schemas.microsoft.com/office/drawing/2014/main" id="{8ED6413A-5DEB-48B6-8B1B-9F76EBCA7A7A}"/>
+                <a16:creationId xmlns:a16="http://schemas.microsoft.com/office/drawing/2014/main" id="{D77AA16E-CC83-479A-8398-AE76DA6170D3}"/>
               </a:ext>
             </a:extLst>
           </p:cNvPr>
@@ -7399,7 +7367,7 @@
           <p:cNvPr id="20" name="">
             <a:extLst xmlns:a="http://schemas.openxmlformats.org/drawingml/2006/main">
               <a:ext uri="{FF2B5EF4-FFF2-40B4-BE49-F238E27FC236}">
-                <a16:creationId xmlns:a16="http://schemas.microsoft.com/office/drawing/2014/main" id="{C76A29F8-6773-4300-A333-BE330D275D06}"/>
+                <a16:creationId xmlns:a16="http://schemas.microsoft.com/office/drawing/2014/main" id="{D4F88E8E-B2B7-4E94-96FA-00DA9C66D64A}"/>
               </a:ext>
             </a:extLst>
           </p:cNvPr>
@@ -7430,7 +7398,7 @@
           <p:cNvPr id="21" name="">
             <a:extLst xmlns:a="http://schemas.openxmlformats.org/drawingml/2006/main">
               <a:ext uri="{FF2B5EF4-FFF2-40B4-BE49-F238E27FC236}">
-                <a16:creationId xmlns:a16="http://schemas.microsoft.com/office/drawing/2014/main" id="{E1DA1556-F0EC-4054-B8E5-6B3708894670}"/>
+                <a16:creationId xmlns:a16="http://schemas.microsoft.com/office/drawing/2014/main" id="{4621F18C-049C-4058-9727-00DA83E5C73D}"/>
               </a:ext>
             </a:extLst>
           </p:cNvPr>
@@ -7486,7 +7454,7 @@
           <p:cNvPr id="22" name="">
             <a:extLst xmlns:a="http://schemas.openxmlformats.org/drawingml/2006/main">
               <a:ext uri="{FF2B5EF4-FFF2-40B4-BE49-F238E27FC236}">
-                <a16:creationId xmlns:a16="http://schemas.microsoft.com/office/drawing/2014/main" id="{B9381D67-8182-4D3F-87F2-75292FCCDC0C}"/>
+                <a16:creationId xmlns:a16="http://schemas.microsoft.com/office/drawing/2014/main" id="{9345FCCB-4C53-4922-BD70-609A1642B60A}"/>
               </a:ext>
             </a:extLst>
           </p:cNvPr>
@@ -7517,7 +7485,7 @@
           <p:cNvPr id="23" name="">
             <a:extLst xmlns:a="http://schemas.openxmlformats.org/drawingml/2006/main">
               <a:ext uri="{FF2B5EF4-FFF2-40B4-BE49-F238E27FC236}">
-                <a16:creationId xmlns:a16="http://schemas.microsoft.com/office/drawing/2014/main" id="{A4E8868A-65BB-416F-B1A6-4D48E1FF1414}"/>
+                <a16:creationId xmlns:a16="http://schemas.microsoft.com/office/drawing/2014/main" id="{DBBF21BE-557D-4413-9076-5A528081AC73}"/>
               </a:ext>
             </a:extLst>
           </p:cNvPr>
@@ -7573,7 +7541,7 @@
           <p:cNvPr id="24" name="">
             <a:extLst xmlns:a="http://schemas.openxmlformats.org/drawingml/2006/main">
               <a:ext uri="{FF2B5EF4-FFF2-40B4-BE49-F238E27FC236}">
-                <a16:creationId xmlns:a16="http://schemas.microsoft.com/office/drawing/2014/main" id="{0034EDD4-59CA-4674-8E55-912B0FB1C4B1}"/>
+                <a16:creationId xmlns:a16="http://schemas.microsoft.com/office/drawing/2014/main" id="{A9ACA62A-C804-46FD-88FC-6901562D1EBE}"/>
               </a:ext>
             </a:extLst>
           </p:cNvPr>
@@ -7604,7 +7572,7 @@
           <p:cNvPr id="25" name="">
             <a:extLst xmlns:a="http://schemas.openxmlformats.org/drawingml/2006/main">
               <a:ext uri="{FF2B5EF4-FFF2-40B4-BE49-F238E27FC236}">
-                <a16:creationId xmlns:a16="http://schemas.microsoft.com/office/drawing/2014/main" id="{968646C8-F158-4F0D-A172-91F419D7C4CC}"/>
+                <a16:creationId xmlns:a16="http://schemas.microsoft.com/office/drawing/2014/main" id="{8C1BBCAE-A554-4E0A-9A61-9BC4C07198AA}"/>
               </a:ext>
             </a:extLst>
           </p:cNvPr>
@@ -7660,7 +7628,7 @@
           <p:cNvPr id="26" name="">
             <a:extLst xmlns:a="http://schemas.openxmlformats.org/drawingml/2006/main">
               <a:ext uri="{FF2B5EF4-FFF2-40B4-BE49-F238E27FC236}">
-                <a16:creationId xmlns:a16="http://schemas.microsoft.com/office/drawing/2014/main" id="{522765DD-164B-4D4A-B244-83CA3474BC8A}"/>
+                <a16:creationId xmlns:a16="http://schemas.microsoft.com/office/drawing/2014/main" id="{23469806-8997-42F7-9335-5161FA2E45B7}"/>
               </a:ext>
             </a:extLst>
           </p:cNvPr>
@@ -7691,7 +7659,7 @@
           <p:cNvPr id="27" name="">
             <a:extLst xmlns:a="http://schemas.openxmlformats.org/drawingml/2006/main">
               <a:ext uri="{FF2B5EF4-FFF2-40B4-BE49-F238E27FC236}">
-                <a16:creationId xmlns:a16="http://schemas.microsoft.com/office/drawing/2014/main" id="{3DC7C1C0-967A-428C-86A1-A13E918A1DBA}"/>
+                <a16:creationId xmlns:a16="http://schemas.microsoft.com/office/drawing/2014/main" id="{E6EAD447-9ACD-42BC-AB2E-B933555082FA}"/>
               </a:ext>
             </a:extLst>
           </p:cNvPr>
@@ -7747,7 +7715,7 @@
           <p:cNvPr id="28" name="">
             <a:extLst xmlns:a="http://schemas.openxmlformats.org/drawingml/2006/main">
               <a:ext uri="{FF2B5EF4-FFF2-40B4-BE49-F238E27FC236}">
-                <a16:creationId xmlns:a16="http://schemas.microsoft.com/office/drawing/2014/main" id="{AB7DEF64-ECA6-4572-8A37-006CACAFB086}"/>
+                <a16:creationId xmlns:a16="http://schemas.microsoft.com/office/drawing/2014/main" id="{06FEDC4F-495E-4D06-B319-96F381DD8AB0}"/>
               </a:ext>
             </a:extLst>
           </p:cNvPr>
@@ -7778,7 +7746,7 @@
           <p:cNvPr id="29" name="">
             <a:extLst xmlns:a="http://schemas.openxmlformats.org/drawingml/2006/main">
               <a:ext uri="{FF2B5EF4-FFF2-40B4-BE49-F238E27FC236}">
-                <a16:creationId xmlns:a16="http://schemas.microsoft.com/office/drawing/2014/main" id="{122B3872-24A4-4EC7-888A-CB3E3E5AD026}"/>
+                <a16:creationId xmlns:a16="http://schemas.microsoft.com/office/drawing/2014/main" id="{057AFC29-15B0-4B44-907D-27AA24C8F431}"/>
               </a:ext>
             </a:extLst>
           </p:cNvPr>
@@ -7834,7 +7802,7 @@
           <p:cNvPr id="30" name="">
             <a:extLst xmlns:a="http://schemas.openxmlformats.org/drawingml/2006/main">
               <a:ext uri="{FF2B5EF4-FFF2-40B4-BE49-F238E27FC236}">
-                <a16:creationId xmlns:a16="http://schemas.microsoft.com/office/drawing/2014/main" id="{57385E20-5803-49D3-857C-D2F20B61BBE4}"/>
+                <a16:creationId xmlns:a16="http://schemas.microsoft.com/office/drawing/2014/main" id="{864E1C35-C8D1-45BF-8071-C020307AB80E}"/>
               </a:ext>
             </a:extLst>
           </p:cNvPr>
@@ -7865,7 +7833,7 @@
           <p:cNvPr id="31" name="">
             <a:extLst xmlns:a="http://schemas.openxmlformats.org/drawingml/2006/main">
               <a:ext uri="{FF2B5EF4-FFF2-40B4-BE49-F238E27FC236}">
-                <a16:creationId xmlns:a16="http://schemas.microsoft.com/office/drawing/2014/main" id="{B294ABF4-2CF8-44EA-B9C9-3D4AB261A6D1}"/>
+                <a16:creationId xmlns:a16="http://schemas.microsoft.com/office/drawing/2014/main" id="{67A2F263-0B62-4DB1-9C04-AE7A0F3E3AA9}"/>
               </a:ext>
             </a:extLst>
           </p:cNvPr>
@@ -7921,7 +7889,7 @@
           <p:cNvPr id="32" name="">
             <a:extLst xmlns:a="http://schemas.openxmlformats.org/drawingml/2006/main">
               <a:ext uri="{FF2B5EF4-FFF2-40B4-BE49-F238E27FC236}">
-                <a16:creationId xmlns:a16="http://schemas.microsoft.com/office/drawing/2014/main" id="{969A6AD1-8AEB-42C1-AAC1-C9246AD98940}"/>
+                <a16:creationId xmlns:a16="http://schemas.microsoft.com/office/drawing/2014/main" id="{48151489-0E63-40DF-9DC9-2748946E0D1A}"/>
               </a:ext>
             </a:extLst>
           </p:cNvPr>
@@ -7954,7 +7922,7 @@
           <p:cNvPr id="33" name="">
             <a:extLst xmlns:a="http://schemas.openxmlformats.org/drawingml/2006/main">
               <a:ext uri="{FF2B5EF4-FFF2-40B4-BE49-F238E27FC236}">
-                <a16:creationId xmlns:a16="http://schemas.microsoft.com/office/drawing/2014/main" id="{FC77F5F3-2D24-482D-A9BF-FEE0D57A0800}"/>
+                <a16:creationId xmlns:a16="http://schemas.microsoft.com/office/drawing/2014/main" id="{D45F9D47-8279-46A9-8957-F13CC5541272}"/>
               </a:ext>
             </a:extLst>
           </p:cNvPr>
@@ -8010,7 +7978,7 @@
           <p:cNvPr id="34" name="">
             <a:extLst xmlns:a="http://schemas.openxmlformats.org/drawingml/2006/main">
               <a:ext uri="{FF2B5EF4-FFF2-40B4-BE49-F238E27FC236}">
-                <a16:creationId xmlns:a16="http://schemas.microsoft.com/office/drawing/2014/main" id="{15FD863A-E88F-4316-A754-69BC61F90054}"/>
+                <a16:creationId xmlns:a16="http://schemas.microsoft.com/office/drawing/2014/main" id="{E7ADBEC5-6DB9-4508-B889-FC59D3482F2D}"/>
               </a:ext>
             </a:extLst>
           </p:cNvPr>
@@ -8041,7 +8009,7 @@
           <p:cNvPr id="35" name="">
             <a:extLst xmlns:a="http://schemas.openxmlformats.org/drawingml/2006/main">
               <a:ext uri="{FF2B5EF4-FFF2-40B4-BE49-F238E27FC236}">
-                <a16:creationId xmlns:a16="http://schemas.microsoft.com/office/drawing/2014/main" id="{E40961AE-7318-455B-9A00-3537AD465B56}"/>
+                <a16:creationId xmlns:a16="http://schemas.microsoft.com/office/drawing/2014/main" id="{F42939C7-5E61-4B77-9558-A52D06A76274}"/>
               </a:ext>
             </a:extLst>
           </p:cNvPr>
@@ -8097,7 +8065,7 @@
           <p:cNvPr id="36" name="">
             <a:extLst xmlns:a="http://schemas.openxmlformats.org/drawingml/2006/main">
               <a:ext uri="{FF2B5EF4-FFF2-40B4-BE49-F238E27FC236}">
-                <a16:creationId xmlns:a16="http://schemas.microsoft.com/office/drawing/2014/main" id="{B813C8BB-8FEB-4CEE-B429-C75BAB10E708}"/>
+                <a16:creationId xmlns:a16="http://schemas.microsoft.com/office/drawing/2014/main" id="{3EFA475A-9649-4038-8F4B-7828C5DE4107}"/>
               </a:ext>
             </a:extLst>
           </p:cNvPr>
@@ -8128,7 +8096,7 @@
           <p:cNvPr id="37" name="">
             <a:extLst xmlns:a="http://schemas.openxmlformats.org/drawingml/2006/main">
               <a:ext uri="{FF2B5EF4-FFF2-40B4-BE49-F238E27FC236}">
-                <a16:creationId xmlns:a16="http://schemas.microsoft.com/office/drawing/2014/main" id="{FF58EE22-4C64-4848-903E-D2B885E4D618}"/>
+                <a16:creationId xmlns:a16="http://schemas.microsoft.com/office/drawing/2014/main" id="{08874B75-73D5-4ADC-A1D0-7FF82E9A7F4F}"/>
               </a:ext>
             </a:extLst>
           </p:cNvPr>
@@ -8184,7 +8152,7 @@
           <p:cNvPr id="38" name="">
             <a:extLst xmlns:a="http://schemas.openxmlformats.org/drawingml/2006/main">
               <a:ext uri="{FF2B5EF4-FFF2-40B4-BE49-F238E27FC236}">
-                <a16:creationId xmlns:a16="http://schemas.microsoft.com/office/drawing/2014/main" id="{D75CC693-C1C8-44A3-A263-317CA6118C8D}"/>
+                <a16:creationId xmlns:a16="http://schemas.microsoft.com/office/drawing/2014/main" id="{6CC20C05-FA2B-40D0-9E8D-4E404A8B8825}"/>
               </a:ext>
             </a:extLst>
           </p:cNvPr>
@@ -8215,7 +8183,7 @@
           <p:cNvPr id="39" name="">
             <a:extLst xmlns:a="http://schemas.openxmlformats.org/drawingml/2006/main">
               <a:ext uri="{FF2B5EF4-FFF2-40B4-BE49-F238E27FC236}">
-                <a16:creationId xmlns:a16="http://schemas.microsoft.com/office/drawing/2014/main" id="{0E166EAB-EE51-4295-891F-BA8E3E174E26}"/>
+                <a16:creationId xmlns:a16="http://schemas.microsoft.com/office/drawing/2014/main" id="{99771957-FE0B-4AE1-AA13-4118EDB53771}"/>
               </a:ext>
             </a:extLst>
           </p:cNvPr>
@@ -8271,7 +8239,7 @@
           <p:cNvPr id="40" name="">
             <a:extLst xmlns:a="http://schemas.openxmlformats.org/drawingml/2006/main">
               <a:ext uri="{FF2B5EF4-FFF2-40B4-BE49-F238E27FC236}">
-                <a16:creationId xmlns:a16="http://schemas.microsoft.com/office/drawing/2014/main" id="{A877B4FC-FC58-462E-8740-1AEC29210338}"/>
+                <a16:creationId xmlns:a16="http://schemas.microsoft.com/office/drawing/2014/main" id="{BF0DDCE6-573E-4109-A667-78BD0C76D052}"/>
               </a:ext>
             </a:extLst>
           </p:cNvPr>
@@ -8302,7 +8270,7 @@
           <p:cNvPr id="41" name="">
             <a:extLst xmlns:a="http://schemas.openxmlformats.org/drawingml/2006/main">
               <a:ext uri="{FF2B5EF4-FFF2-40B4-BE49-F238E27FC236}">
-                <a16:creationId xmlns:a16="http://schemas.microsoft.com/office/drawing/2014/main" id="{DB295816-80E9-48B8-BCC4-7B1385228FF6}"/>
+                <a16:creationId xmlns:a16="http://schemas.microsoft.com/office/drawing/2014/main" id="{E157E20A-056A-471C-8BB2-768B40AABADF}"/>
               </a:ext>
             </a:extLst>
           </p:cNvPr>
@@ -8358,7 +8326,7 @@
           <p:cNvPr id="42" name="">
             <a:extLst xmlns:a="http://schemas.openxmlformats.org/drawingml/2006/main">
               <a:ext uri="{FF2B5EF4-FFF2-40B4-BE49-F238E27FC236}">
-                <a16:creationId xmlns:a16="http://schemas.microsoft.com/office/drawing/2014/main" id="{4CAD9799-995D-46A8-A14A-EB16A4E7906E}"/>
+                <a16:creationId xmlns:a16="http://schemas.microsoft.com/office/drawing/2014/main" id="{904CB49D-17C3-4003-9855-7EB0BE99DDFD}"/>
               </a:ext>
             </a:extLst>
           </p:cNvPr>
@@ -8389,7 +8357,7 @@
           <p:cNvPr id="43" name="">
             <a:extLst xmlns:a="http://schemas.openxmlformats.org/drawingml/2006/main">
               <a:ext uri="{FF2B5EF4-FFF2-40B4-BE49-F238E27FC236}">
-                <a16:creationId xmlns:a16="http://schemas.microsoft.com/office/drawing/2014/main" id="{24A8CB95-D50F-4925-998B-4A1CC9651051}"/>
+                <a16:creationId xmlns:a16="http://schemas.microsoft.com/office/drawing/2014/main" id="{446C3C0F-5D68-4070-ACE1-B7CFB89FDB14}"/>
               </a:ext>
             </a:extLst>
           </p:cNvPr>
@@ -8445,7 +8413,7 @@
           <p:cNvPr id="44" name="">
             <a:extLst xmlns:a="http://schemas.openxmlformats.org/drawingml/2006/main">
               <a:ext uri="{FF2B5EF4-FFF2-40B4-BE49-F238E27FC236}">
-                <a16:creationId xmlns:a16="http://schemas.microsoft.com/office/drawing/2014/main" id="{F75E1252-29CD-4A46-9BD0-7A539736EECB}"/>
+                <a16:creationId xmlns:a16="http://schemas.microsoft.com/office/drawing/2014/main" id="{81D8D858-50CA-4F09-98C3-4FC1F8FF6994}"/>
               </a:ext>
             </a:extLst>
           </p:cNvPr>
@@ -8476,7 +8444,7 @@
           <p:cNvPr id="45" name="">
             <a:extLst xmlns:a="http://schemas.openxmlformats.org/drawingml/2006/main">
               <a:ext uri="{FF2B5EF4-FFF2-40B4-BE49-F238E27FC236}">
-                <a16:creationId xmlns:a16="http://schemas.microsoft.com/office/drawing/2014/main" id="{6BD9C005-D926-401A-AA57-50D233A88D8B}"/>
+                <a16:creationId xmlns:a16="http://schemas.microsoft.com/office/drawing/2014/main" id="{FDE8F800-C6D2-4831-AEB6-088A408A1525}"/>
               </a:ext>
             </a:extLst>
           </p:cNvPr>
@@ -8532,7 +8500,7 @@
           <p:cNvPr id="46" name="">
             <a:extLst xmlns:a="http://schemas.openxmlformats.org/drawingml/2006/main">
               <a:ext uri="{FF2B5EF4-FFF2-40B4-BE49-F238E27FC236}">
-                <a16:creationId xmlns:a16="http://schemas.microsoft.com/office/drawing/2014/main" id="{487D74D7-AD48-4C64-A6C4-2F6C08AA172B}"/>
+                <a16:creationId xmlns:a16="http://schemas.microsoft.com/office/drawing/2014/main" id="{CEED94E0-1783-4F09-BCE4-5EF414F01880}"/>
               </a:ext>
             </a:extLst>
           </p:cNvPr>
@@ -8565,7 +8533,7 @@
           <p:cNvPr id="47" name="">
             <a:extLst xmlns:a="http://schemas.openxmlformats.org/drawingml/2006/main">
               <a:ext uri="{FF2B5EF4-FFF2-40B4-BE49-F238E27FC236}">
-                <a16:creationId xmlns:a16="http://schemas.microsoft.com/office/drawing/2014/main" id="{4CDEB89A-74B3-4516-9E18-C89EC6D68F2F}"/>
+                <a16:creationId xmlns:a16="http://schemas.microsoft.com/office/drawing/2014/main" id="{32815191-BF56-4A1F-B741-0DF415E1C12E}"/>
               </a:ext>
             </a:extLst>
           </p:cNvPr>
@@ -8621,7 +8589,7 @@
           <p:cNvPr id="48" name="">
             <a:extLst xmlns:a="http://schemas.openxmlformats.org/drawingml/2006/main">
               <a:ext uri="{FF2B5EF4-FFF2-40B4-BE49-F238E27FC236}">
-                <a16:creationId xmlns:a16="http://schemas.microsoft.com/office/drawing/2014/main" id="{CA541EDD-473A-40A6-ACE9-FB4BEF2B3185}"/>
+                <a16:creationId xmlns:a16="http://schemas.microsoft.com/office/drawing/2014/main" id="{56F80D36-EC90-4D54-A407-B7E82A9A7769}"/>
               </a:ext>
             </a:extLst>
           </p:cNvPr>
@@ -8652,7 +8620,7 @@
           <p:cNvPr id="49" name="">
             <a:extLst xmlns:a="http://schemas.openxmlformats.org/drawingml/2006/main">
               <a:ext uri="{FF2B5EF4-FFF2-40B4-BE49-F238E27FC236}">
-                <a16:creationId xmlns:a16="http://schemas.microsoft.com/office/drawing/2014/main" id="{74D9ABF1-DEBB-465A-B516-A49692BBCE00}"/>
+                <a16:creationId xmlns:a16="http://schemas.microsoft.com/office/drawing/2014/main" id="{3C0AB0D8-A37E-43C4-8457-033F0C05B664}"/>
               </a:ext>
             </a:extLst>
           </p:cNvPr>
@@ -8708,7 +8676,7 @@
           <p:cNvPr id="50" name="">
             <a:extLst xmlns:a="http://schemas.openxmlformats.org/drawingml/2006/main">
               <a:ext uri="{FF2B5EF4-FFF2-40B4-BE49-F238E27FC236}">
-                <a16:creationId xmlns:a16="http://schemas.microsoft.com/office/drawing/2014/main" id="{DE2EA442-CCB8-4DE8-8736-9382D1159C2F}"/>
+                <a16:creationId xmlns:a16="http://schemas.microsoft.com/office/drawing/2014/main" id="{A11A791C-B8D3-4240-A9F3-3FE2C746AE91}"/>
               </a:ext>
             </a:extLst>
           </p:cNvPr>
@@ -8739,7 +8707,7 @@
           <p:cNvPr id="51" name="">
             <a:extLst xmlns:a="http://schemas.openxmlformats.org/drawingml/2006/main">
               <a:ext uri="{FF2B5EF4-FFF2-40B4-BE49-F238E27FC236}">
-                <a16:creationId xmlns:a16="http://schemas.microsoft.com/office/drawing/2014/main" id="{D6A80E3B-7F77-474E-9D60-DBB1138E9260}"/>
+                <a16:creationId xmlns:a16="http://schemas.microsoft.com/office/drawing/2014/main" id="{8F23991F-5B0E-4004-92BA-3EAC94D00561}"/>
               </a:ext>
             </a:extLst>
           </p:cNvPr>
@@ -8795,7 +8763,7 @@
           <p:cNvPr id="52" name="">
             <a:extLst xmlns:a="http://schemas.openxmlformats.org/drawingml/2006/main">
               <a:ext uri="{FF2B5EF4-FFF2-40B4-BE49-F238E27FC236}">
-                <a16:creationId xmlns:a16="http://schemas.microsoft.com/office/drawing/2014/main" id="{A0D6C8E1-BA3D-464B-9FE7-E872AF87F952}"/>
+                <a16:creationId xmlns:a16="http://schemas.microsoft.com/office/drawing/2014/main" id="{094CFDC6-55A1-408D-BD46-467CB7F39E5D}"/>
               </a:ext>
             </a:extLst>
           </p:cNvPr>
@@ -8826,7 +8794,7 @@
           <p:cNvPr id="53" name="">
             <a:extLst xmlns:a="http://schemas.openxmlformats.org/drawingml/2006/main">
               <a:ext uri="{FF2B5EF4-FFF2-40B4-BE49-F238E27FC236}">
-                <a16:creationId xmlns:a16="http://schemas.microsoft.com/office/drawing/2014/main" id="{56A7175A-87D7-4053-8019-351261DC73E4}"/>
+                <a16:creationId xmlns:a16="http://schemas.microsoft.com/office/drawing/2014/main" id="{98912E28-DDA5-45A0-B04D-938CF8ED3746}"/>
               </a:ext>
             </a:extLst>
           </p:cNvPr>
@@ -8882,7 +8850,7 @@
           <p:cNvPr id="54" name="">
             <a:extLst xmlns:a="http://schemas.openxmlformats.org/drawingml/2006/main">
               <a:ext uri="{FF2B5EF4-FFF2-40B4-BE49-F238E27FC236}">
-                <a16:creationId xmlns:a16="http://schemas.microsoft.com/office/drawing/2014/main" id="{64BE64A6-F6BD-425E-B8A4-E7EFB86A43AB}"/>
+                <a16:creationId xmlns:a16="http://schemas.microsoft.com/office/drawing/2014/main" id="{6AF4074B-69B8-437A-B20F-02AF2D87325E}"/>
               </a:ext>
             </a:extLst>
           </p:cNvPr>
@@ -8913,7 +8881,7 @@
           <p:cNvPr id="55" name="">
             <a:extLst xmlns:a="http://schemas.openxmlformats.org/drawingml/2006/main">
               <a:ext uri="{FF2B5EF4-FFF2-40B4-BE49-F238E27FC236}">
-                <a16:creationId xmlns:a16="http://schemas.microsoft.com/office/drawing/2014/main" id="{C01D39B3-DA58-461A-A3D7-32BD9F4FCD14}"/>
+                <a16:creationId xmlns:a16="http://schemas.microsoft.com/office/drawing/2014/main" id="{E8BA257D-BB78-4E22-BA22-1F2670AAA88A}"/>
               </a:ext>
             </a:extLst>
           </p:cNvPr>
@@ -8969,7 +8937,7 @@
           <p:cNvPr id="56" name="">
             <a:extLst xmlns:a="http://schemas.openxmlformats.org/drawingml/2006/main">
               <a:ext uri="{FF2B5EF4-FFF2-40B4-BE49-F238E27FC236}">
-                <a16:creationId xmlns:a16="http://schemas.microsoft.com/office/drawing/2014/main" id="{5AD39B4D-3A30-4BDE-B9DC-E9A4B228AACC}"/>
+                <a16:creationId xmlns:a16="http://schemas.microsoft.com/office/drawing/2014/main" id="{853C4990-AD38-442D-9E80-7B3C01977C12}"/>
               </a:ext>
             </a:extLst>
           </p:cNvPr>
@@ -9000,7 +8968,7 @@
           <p:cNvPr id="57" name="">
             <a:extLst xmlns:a="http://schemas.openxmlformats.org/drawingml/2006/main">
               <a:ext uri="{FF2B5EF4-FFF2-40B4-BE49-F238E27FC236}">
-                <a16:creationId xmlns:a16="http://schemas.microsoft.com/office/drawing/2014/main" id="{46EBF485-E3E0-4230-8885-8A5E8A5D48D3}"/>
+                <a16:creationId xmlns:a16="http://schemas.microsoft.com/office/drawing/2014/main" id="{40E26214-B68F-412D-9663-C1D0A1BEB114}"/>
               </a:ext>
             </a:extLst>
           </p:cNvPr>
@@ -9056,7 +9024,7 @@
           <p:cNvPr id="58" name="">
             <a:extLst xmlns:a="http://schemas.openxmlformats.org/drawingml/2006/main">
               <a:ext uri="{FF2B5EF4-FFF2-40B4-BE49-F238E27FC236}">
-                <a16:creationId xmlns:a16="http://schemas.microsoft.com/office/drawing/2014/main" id="{79F7125E-DCC3-458D-8994-09B01833ED3C}"/>
+                <a16:creationId xmlns:a16="http://schemas.microsoft.com/office/drawing/2014/main" id="{A0AAFA9C-5D0E-448B-BEBF-62BA6F9D83A1}"/>
               </a:ext>
             </a:extLst>
           </p:cNvPr>
@@ -9087,7 +9055,7 @@
           <p:cNvPr id="59" name="">
             <a:extLst xmlns:a="http://schemas.openxmlformats.org/drawingml/2006/main">
               <a:ext uri="{FF2B5EF4-FFF2-40B4-BE49-F238E27FC236}">
-                <a16:creationId xmlns:a16="http://schemas.microsoft.com/office/drawing/2014/main" id="{9E405B85-4092-459B-B6BB-3D52C8200FCC}"/>
+                <a16:creationId xmlns:a16="http://schemas.microsoft.com/office/drawing/2014/main" id="{4313C4FD-6D19-44EC-BBAD-D8FA285E4F5B}"/>
               </a:ext>
             </a:extLst>
           </p:cNvPr>
@@ -9150,14 +9118,14 @@
         </p:xfrm>
         <a:graphic xmlns:a="http://schemas.openxmlformats.org/drawingml/2006/main">
           <a:graphicData uri="http://schemas.openxmlformats.org/drawingml/2006/chart">
-            <c:chart xmlns:r="http://schemas.openxmlformats.org/officeDocument/2006/relationships" xmlns:c="http://schemas.openxmlformats.org/drawingml/2006/chart" r:id="Rd37a70b9828f4780"/>
+            <c:chart xmlns:r="http://schemas.openxmlformats.org/officeDocument/2006/relationships" xmlns:c="http://schemas.openxmlformats.org/drawingml/2006/chart" r:id="R225704f29db94e6d"/>
           </a:graphicData>
         </a:graphic>
       </p:graphicFrame>
     </p:spTree>
     <p:extLst>
       <p:ext uri="{BB962C8B-B14F-4D97-AF65-F5344CB8AC3E}">
-        <p14:creationId xmlns:p14="http://schemas.microsoft.com/office/powerpoint/2010/main" val="286244219"/>
+        <p14:creationId xmlns:p14="http://schemas.microsoft.com/office/powerpoint/2010/main" val="522810251"/>
       </p:ext>
     </p:extLst>
   </p:cSld>
@@ -9188,7 +9156,7 @@
           <p:cNvPr id="1" name="">
             <a:extLst xmlns:a="http://schemas.openxmlformats.org/drawingml/2006/main">
               <a:ext uri="{FF2B5EF4-FFF2-40B4-BE49-F238E27FC236}">
-                <a16:creationId xmlns:a16="http://schemas.microsoft.com/office/drawing/2014/main" id="{319DE1C7-DEB8-4EC5-816E-1E50A0A605C4}"/>
+                <a16:creationId xmlns:a16="http://schemas.microsoft.com/office/drawing/2014/main" id="{8A2F6DCC-4E7F-4CCB-ADCC-F8AADCDD1210}"/>
               </a:ext>
             </a:extLst>
           </p:cNvPr>
@@ -9244,7 +9212,7 @@
           <p:cNvPr id="2" name="">
             <a:extLst xmlns:a="http://schemas.openxmlformats.org/drawingml/2006/main">
               <a:ext uri="{FF2B5EF4-FFF2-40B4-BE49-F238E27FC236}">
-                <a16:creationId xmlns:a16="http://schemas.microsoft.com/office/drawing/2014/main" id="{08D2F55E-D480-4194-8ABC-18E824456B5C}"/>
+                <a16:creationId xmlns:a16="http://schemas.microsoft.com/office/drawing/2014/main" id="{F54A7CA5-85BC-493A-A5A8-8742FA6B630B}"/>
               </a:ext>
             </a:extLst>
           </p:cNvPr>
@@ -9275,7 +9243,7 @@
           <p:cNvPr id="3" name="">
             <a:extLst xmlns:a="http://schemas.openxmlformats.org/drawingml/2006/main">
               <a:ext uri="{FF2B5EF4-FFF2-40B4-BE49-F238E27FC236}">
-                <a16:creationId xmlns:a16="http://schemas.microsoft.com/office/drawing/2014/main" id="{3BCF42A8-C775-4C2B-A6F1-1433B282E5F6}"/>
+                <a16:creationId xmlns:a16="http://schemas.microsoft.com/office/drawing/2014/main" id="{6F7E355E-4025-4AFA-84E4-0EB98B32AFEF}"/>
               </a:ext>
             </a:extLst>
           </p:cNvPr>
@@ -9331,7 +9299,7 @@
           <p:cNvPr id="4" name="">
             <a:extLst xmlns:a="http://schemas.openxmlformats.org/drawingml/2006/main">
               <a:ext uri="{FF2B5EF4-FFF2-40B4-BE49-F238E27FC236}">
-                <a16:creationId xmlns:a16="http://schemas.microsoft.com/office/drawing/2014/main" id="{7FF2E4F7-9AB0-495B-9EE8-C362FDC053F5}"/>
+                <a16:creationId xmlns:a16="http://schemas.microsoft.com/office/drawing/2014/main" id="{374611A2-128D-4203-BB56-60F8F9380E17}"/>
               </a:ext>
             </a:extLst>
           </p:cNvPr>
@@ -9364,7 +9332,7 @@
           <p:cNvPr id="5" name="">
             <a:extLst xmlns:a="http://schemas.openxmlformats.org/drawingml/2006/main">
               <a:ext uri="{FF2B5EF4-FFF2-40B4-BE49-F238E27FC236}">
-                <a16:creationId xmlns:a16="http://schemas.microsoft.com/office/drawing/2014/main" id="{851C0B00-473D-4D07-80CC-395022BB3652}"/>
+                <a16:creationId xmlns:a16="http://schemas.microsoft.com/office/drawing/2014/main" id="{5D19E2BC-9A77-457D-BD5E-876C03563A82}"/>
               </a:ext>
             </a:extLst>
           </p:cNvPr>
@@ -9420,7 +9388,7 @@
           <p:cNvPr id="6" name="">
             <a:extLst xmlns:a="http://schemas.openxmlformats.org/drawingml/2006/main">
               <a:ext uri="{FF2B5EF4-FFF2-40B4-BE49-F238E27FC236}">
-                <a16:creationId xmlns:a16="http://schemas.microsoft.com/office/drawing/2014/main" id="{FE3417C5-DC4D-46BB-A9B5-F019D317FC6A}"/>
+                <a16:creationId xmlns:a16="http://schemas.microsoft.com/office/drawing/2014/main" id="{A8C1904B-FA8C-42AA-BE4B-C78C532AA64D}"/>
               </a:ext>
             </a:extLst>
           </p:cNvPr>
@@ -9451,7 +9419,7 @@
           <p:cNvPr id="7" name="">
             <a:extLst xmlns:a="http://schemas.openxmlformats.org/drawingml/2006/main">
               <a:ext uri="{FF2B5EF4-FFF2-40B4-BE49-F238E27FC236}">
-                <a16:creationId xmlns:a16="http://schemas.microsoft.com/office/drawing/2014/main" id="{62DE5BC5-949B-4C6B-8E5A-ED05CD964D4A}"/>
+                <a16:creationId xmlns:a16="http://schemas.microsoft.com/office/drawing/2014/main" id="{F2A643D5-2B68-4175-9EE5-6E244CA7370B}"/>
               </a:ext>
             </a:extLst>
           </p:cNvPr>
@@ -9507,7 +9475,7 @@
           <p:cNvPr id="8" name="">
             <a:extLst xmlns:a="http://schemas.openxmlformats.org/drawingml/2006/main">
               <a:ext uri="{FF2B5EF4-FFF2-40B4-BE49-F238E27FC236}">
-                <a16:creationId xmlns:a16="http://schemas.microsoft.com/office/drawing/2014/main" id="{6CC0462C-487A-4CCD-B397-7832D4408FD8}"/>
+                <a16:creationId xmlns:a16="http://schemas.microsoft.com/office/drawing/2014/main" id="{EEA9463E-6306-4F83-97BF-EAA40E7081FF}"/>
               </a:ext>
             </a:extLst>
           </p:cNvPr>
@@ -9538,7 +9506,7 @@
           <p:cNvPr id="9" name="">
             <a:extLst xmlns:a="http://schemas.openxmlformats.org/drawingml/2006/main">
               <a:ext uri="{FF2B5EF4-FFF2-40B4-BE49-F238E27FC236}">
-                <a16:creationId xmlns:a16="http://schemas.microsoft.com/office/drawing/2014/main" id="{D4AC8191-2AE8-4FFE-B307-30BC9E1311CE}"/>
+                <a16:creationId xmlns:a16="http://schemas.microsoft.com/office/drawing/2014/main" id="{CDF3455A-AC51-45D6-94A2-838491903C04}"/>
               </a:ext>
             </a:extLst>
           </p:cNvPr>
@@ -9594,7 +9562,7 @@
           <p:cNvPr id="10" name="">
             <a:extLst xmlns:a="http://schemas.openxmlformats.org/drawingml/2006/main">
               <a:ext uri="{FF2B5EF4-FFF2-40B4-BE49-F238E27FC236}">
-                <a16:creationId xmlns:a16="http://schemas.microsoft.com/office/drawing/2014/main" id="{5B6EA1C2-9407-43C0-B6E9-65D66EB01518}"/>
+                <a16:creationId xmlns:a16="http://schemas.microsoft.com/office/drawing/2014/main" id="{933683F7-71BA-4839-8C8C-D184C204E4C4}"/>
               </a:ext>
             </a:extLst>
           </p:cNvPr>
@@ -9627,7 +9595,7 @@
           <p:cNvPr id="11" name="">
             <a:extLst xmlns:a="http://schemas.openxmlformats.org/drawingml/2006/main">
               <a:ext uri="{FF2B5EF4-FFF2-40B4-BE49-F238E27FC236}">
-                <a16:creationId xmlns:a16="http://schemas.microsoft.com/office/drawing/2014/main" id="{EE3CD63A-37B8-4A20-B258-594AF0CC05FC}"/>
+                <a16:creationId xmlns:a16="http://schemas.microsoft.com/office/drawing/2014/main" id="{6EB08E25-7F85-40DE-BBED-21EAF2D8646A}"/>
               </a:ext>
             </a:extLst>
           </p:cNvPr>
@@ -9683,7 +9651,7 @@
           <p:cNvPr id="12" name="">
             <a:extLst xmlns:a="http://schemas.openxmlformats.org/drawingml/2006/main">
               <a:ext uri="{FF2B5EF4-FFF2-40B4-BE49-F238E27FC236}">
-                <a16:creationId xmlns:a16="http://schemas.microsoft.com/office/drawing/2014/main" id="{EF463841-9018-413C-96C4-F0417698411D}"/>
+                <a16:creationId xmlns:a16="http://schemas.microsoft.com/office/drawing/2014/main" id="{30E7A06D-D814-4B70-9C7C-C4677A9E34B5}"/>
               </a:ext>
             </a:extLst>
           </p:cNvPr>
@@ -9714,7 +9682,7 @@
           <p:cNvPr id="13" name="">
             <a:extLst xmlns:a="http://schemas.openxmlformats.org/drawingml/2006/main">
               <a:ext uri="{FF2B5EF4-FFF2-40B4-BE49-F238E27FC236}">
-                <a16:creationId xmlns:a16="http://schemas.microsoft.com/office/drawing/2014/main" id="{A7955523-6C0E-4FF6-8B8E-82E4933AFF60}"/>
+                <a16:creationId xmlns:a16="http://schemas.microsoft.com/office/drawing/2014/main" id="{2B8BD5E8-DD60-4AB1-A264-EC089CDD95F4}"/>
               </a:ext>
             </a:extLst>
           </p:cNvPr>
@@ -9770,7 +9738,7 @@
           <p:cNvPr id="14" name="">
             <a:extLst xmlns:a="http://schemas.openxmlformats.org/drawingml/2006/main">
               <a:ext uri="{FF2B5EF4-FFF2-40B4-BE49-F238E27FC236}">
-                <a16:creationId xmlns:a16="http://schemas.microsoft.com/office/drawing/2014/main" id="{B666C2DA-D69A-4ECF-8023-954F5712C250}"/>
+                <a16:creationId xmlns:a16="http://schemas.microsoft.com/office/drawing/2014/main" id="{950ED510-2052-481A-92EE-50B200E640D2}"/>
               </a:ext>
             </a:extLst>
           </p:cNvPr>
@@ -9801,7 +9769,7 @@
           <p:cNvPr id="15" name="">
             <a:extLst xmlns:a="http://schemas.openxmlformats.org/drawingml/2006/main">
               <a:ext uri="{FF2B5EF4-FFF2-40B4-BE49-F238E27FC236}">
-                <a16:creationId xmlns:a16="http://schemas.microsoft.com/office/drawing/2014/main" id="{54FD0997-1429-43FA-AB6F-6BFA1A3DCEF0}"/>
+                <a16:creationId xmlns:a16="http://schemas.microsoft.com/office/drawing/2014/main" id="{3329B919-6162-47E2-A877-5EF744A81BBF}"/>
               </a:ext>
             </a:extLst>
           </p:cNvPr>
@@ -9857,7 +9825,7 @@
           <p:cNvPr id="16" name="">
             <a:extLst xmlns:a="http://schemas.openxmlformats.org/drawingml/2006/main">
               <a:ext uri="{FF2B5EF4-FFF2-40B4-BE49-F238E27FC236}">
-                <a16:creationId xmlns:a16="http://schemas.microsoft.com/office/drawing/2014/main" id="{D62D42DE-738F-4C25-B9B3-4CD50243BB35}"/>
+                <a16:creationId xmlns:a16="http://schemas.microsoft.com/office/drawing/2014/main" id="{78E5E6AF-4841-4387-A5EA-4E6EC44DAE21}"/>
               </a:ext>
             </a:extLst>
           </p:cNvPr>
@@ -9890,7 +9858,7 @@
           <p:cNvPr id="17" name="">
             <a:extLst xmlns:a="http://schemas.openxmlformats.org/drawingml/2006/main">
               <a:ext uri="{FF2B5EF4-FFF2-40B4-BE49-F238E27FC236}">
-                <a16:creationId xmlns:a16="http://schemas.microsoft.com/office/drawing/2014/main" id="{CD5AFA63-AF56-43DE-881F-BEB84C8949B8}"/>
+                <a16:creationId xmlns:a16="http://schemas.microsoft.com/office/drawing/2014/main" id="{565ECC9C-BCEF-447A-B285-646F1EFF6D74}"/>
               </a:ext>
             </a:extLst>
           </p:cNvPr>
@@ -9946,7 +9914,7 @@
           <p:cNvPr id="18" name="">
             <a:extLst xmlns:a="http://schemas.openxmlformats.org/drawingml/2006/main">
               <a:ext uri="{FF2B5EF4-FFF2-40B4-BE49-F238E27FC236}">
-                <a16:creationId xmlns:a16="http://schemas.microsoft.com/office/drawing/2014/main" id="{E589D12E-24C0-4C96-92E4-2D273BECCF0B}"/>
+                <a16:creationId xmlns:a16="http://schemas.microsoft.com/office/drawing/2014/main" id="{3DA25E35-077A-462F-BC79-FD778FE077AC}"/>
               </a:ext>
             </a:extLst>
           </p:cNvPr>
@@ -9977,7 +9945,7 @@
           <p:cNvPr id="19" name="">
             <a:extLst xmlns:a="http://schemas.openxmlformats.org/drawingml/2006/main">
               <a:ext uri="{FF2B5EF4-FFF2-40B4-BE49-F238E27FC236}">
-                <a16:creationId xmlns:a16="http://schemas.microsoft.com/office/drawing/2014/main" id="{255D3F99-208F-4FA1-A3D6-5094C8E7F488}"/>
+                <a16:creationId xmlns:a16="http://schemas.microsoft.com/office/drawing/2014/main" id="{505EF181-8359-43EA-B7FF-FD1586AA0BC1}"/>
               </a:ext>
             </a:extLst>
           </p:cNvPr>
@@ -10033,7 +10001,7 @@
           <p:cNvPr id="20" name="">
             <a:extLst xmlns:a="http://schemas.openxmlformats.org/drawingml/2006/main">
               <a:ext uri="{FF2B5EF4-FFF2-40B4-BE49-F238E27FC236}">
-                <a16:creationId xmlns:a16="http://schemas.microsoft.com/office/drawing/2014/main" id="{419954D6-2470-4970-B77E-2AD7A3478D39}"/>
+                <a16:creationId xmlns:a16="http://schemas.microsoft.com/office/drawing/2014/main" id="{34272506-CD9C-4725-88DF-D7138196B90A}"/>
               </a:ext>
             </a:extLst>
           </p:cNvPr>
@@ -10064,7 +10032,7 @@
           <p:cNvPr id="21" name="">
             <a:extLst xmlns:a="http://schemas.openxmlformats.org/drawingml/2006/main">
               <a:ext uri="{FF2B5EF4-FFF2-40B4-BE49-F238E27FC236}">
-                <a16:creationId xmlns:a16="http://schemas.microsoft.com/office/drawing/2014/main" id="{3BDD65CB-573C-4BD4-B463-AFB663E9C6A8}"/>
+                <a16:creationId xmlns:a16="http://schemas.microsoft.com/office/drawing/2014/main" id="{9DB99B09-DF38-4380-BBFC-5D5A21B5107C}"/>
               </a:ext>
             </a:extLst>
           </p:cNvPr>
@@ -10120,7 +10088,7 @@
           <p:cNvPr id="22" name="">
             <a:extLst xmlns:a="http://schemas.openxmlformats.org/drawingml/2006/main">
               <a:ext uri="{FF2B5EF4-FFF2-40B4-BE49-F238E27FC236}">
-                <a16:creationId xmlns:a16="http://schemas.microsoft.com/office/drawing/2014/main" id="{37498EFF-552D-43DF-84C6-69F3D0584E96}"/>
+                <a16:creationId xmlns:a16="http://schemas.microsoft.com/office/drawing/2014/main" id="{BB7F1743-4E19-4E70-B9E6-C7B2A6BF4EC5}"/>
               </a:ext>
             </a:extLst>
           </p:cNvPr>
@@ -10153,7 +10121,7 @@
           <p:cNvPr id="23" name="">
             <a:extLst xmlns:a="http://schemas.openxmlformats.org/drawingml/2006/main">
               <a:ext uri="{FF2B5EF4-FFF2-40B4-BE49-F238E27FC236}">
-                <a16:creationId xmlns:a16="http://schemas.microsoft.com/office/drawing/2014/main" id="{60E8AE50-EEF8-403A-9CBF-561CE799EF86}"/>
+                <a16:creationId xmlns:a16="http://schemas.microsoft.com/office/drawing/2014/main" id="{85955231-1E72-4524-AAA1-9C6EF658A33A}"/>
               </a:ext>
             </a:extLst>
           </p:cNvPr>
@@ -10209,7 +10177,7 @@
           <p:cNvPr id="24" name="">
             <a:extLst xmlns:a="http://schemas.openxmlformats.org/drawingml/2006/main">
               <a:ext uri="{FF2B5EF4-FFF2-40B4-BE49-F238E27FC236}">
-                <a16:creationId xmlns:a16="http://schemas.microsoft.com/office/drawing/2014/main" id="{A2D0FE65-8ED9-48BD-A0B9-4618D44DC999}"/>
+                <a16:creationId xmlns:a16="http://schemas.microsoft.com/office/drawing/2014/main" id="{A89574D0-8A69-46A1-B768-1DBE6B3293CC}"/>
               </a:ext>
             </a:extLst>
           </p:cNvPr>
@@ -10240,7 +10208,7 @@
           <p:cNvPr id="25" name="">
             <a:extLst xmlns:a="http://schemas.openxmlformats.org/drawingml/2006/main">
               <a:ext uri="{FF2B5EF4-FFF2-40B4-BE49-F238E27FC236}">
-                <a16:creationId xmlns:a16="http://schemas.microsoft.com/office/drawing/2014/main" id="{57BD81DD-CF06-4E08-BB3D-B61E52C41A97}"/>
+                <a16:creationId xmlns:a16="http://schemas.microsoft.com/office/drawing/2014/main" id="{5403BEBF-2643-4460-AABA-9A8A538AE7F8}"/>
               </a:ext>
             </a:extLst>
           </p:cNvPr>
@@ -10296,7 +10264,7 @@
           <p:cNvPr id="26" name="">
             <a:extLst xmlns:a="http://schemas.openxmlformats.org/drawingml/2006/main">
               <a:ext uri="{FF2B5EF4-FFF2-40B4-BE49-F238E27FC236}">
-                <a16:creationId xmlns:a16="http://schemas.microsoft.com/office/drawing/2014/main" id="{084B79EC-AC17-4AEB-A634-7C652094A0D8}"/>
+                <a16:creationId xmlns:a16="http://schemas.microsoft.com/office/drawing/2014/main" id="{152F4F78-1AA9-4909-AD07-1085E8996E31}"/>
               </a:ext>
             </a:extLst>
           </p:cNvPr>
@@ -10327,7 +10295,7 @@
           <p:cNvPr id="27" name="">
             <a:extLst xmlns:a="http://schemas.openxmlformats.org/drawingml/2006/main">
               <a:ext uri="{FF2B5EF4-FFF2-40B4-BE49-F238E27FC236}">
-                <a16:creationId xmlns:a16="http://schemas.microsoft.com/office/drawing/2014/main" id="{E93BE4AC-9372-44D0-8941-E0FA1113BBB6}"/>
+                <a16:creationId xmlns:a16="http://schemas.microsoft.com/office/drawing/2014/main" id="{A39984F7-6794-4CC6-8194-5329ABAA0206}"/>
               </a:ext>
             </a:extLst>
           </p:cNvPr>
@@ -10383,7 +10351,7 @@
           <p:cNvPr id="28" name="">
             <a:extLst xmlns:a="http://schemas.openxmlformats.org/drawingml/2006/main">
               <a:ext uri="{FF2B5EF4-FFF2-40B4-BE49-F238E27FC236}">
-                <a16:creationId xmlns:a16="http://schemas.microsoft.com/office/drawing/2014/main" id="{79DB9201-BDE7-4140-86AA-15357D76C95D}"/>
+                <a16:creationId xmlns:a16="http://schemas.microsoft.com/office/drawing/2014/main" id="{627CC476-0573-4ADB-8FAE-4E7F67052D33}"/>
               </a:ext>
             </a:extLst>
           </p:cNvPr>
@@ -10439,7 +10407,7 @@
           <p:cNvPr id="29" name="">
             <a:extLst xmlns:a="http://schemas.openxmlformats.org/drawingml/2006/main">
               <a:ext uri="{FF2B5EF4-FFF2-40B4-BE49-F238E27FC236}">
-                <a16:creationId xmlns:a16="http://schemas.microsoft.com/office/drawing/2014/main" id="{18088A25-D67C-45DC-A466-A972EDA10893}"/>
+                <a16:creationId xmlns:a16="http://schemas.microsoft.com/office/drawing/2014/main" id="{16C27B81-BC0A-4F47-B8D8-046584320375}"/>
               </a:ext>
             </a:extLst>
           </p:cNvPr>
@@ -10495,7 +10463,7 @@
           <p:cNvPr id="30" name="">
             <a:extLst xmlns:a="http://schemas.openxmlformats.org/drawingml/2006/main">
               <a:ext uri="{FF2B5EF4-FFF2-40B4-BE49-F238E27FC236}">
-                <a16:creationId xmlns:a16="http://schemas.microsoft.com/office/drawing/2014/main" id="{43771FA5-A9AC-4E7B-8F4C-984A93AB263C}"/>
+                <a16:creationId xmlns:a16="http://schemas.microsoft.com/office/drawing/2014/main" id="{9F5FBDA2-182E-47FA-9B9A-A865DA74D4E4}"/>
               </a:ext>
             </a:extLst>
           </p:cNvPr>
@@ -10549,7 +10517,7 @@
     </p:spTree>
     <p:extLst>
       <p:ext uri="{BB962C8B-B14F-4D97-AF65-F5344CB8AC3E}">
-        <p14:creationId xmlns:p14="http://schemas.microsoft.com/office/powerpoint/2010/main" val="458513189"/>
+        <p14:creationId xmlns:p14="http://schemas.microsoft.com/office/powerpoint/2010/main" val="591886355"/>
       </p:ext>
     </p:extLst>
   </p:cSld>
@@ -10580,7 +10548,7 @@
           <p:cNvPr id="1" name="">
             <a:extLst xmlns:a="http://schemas.openxmlformats.org/drawingml/2006/main">
               <a:ext uri="{FF2B5EF4-FFF2-40B4-BE49-F238E27FC236}">
-                <a16:creationId xmlns:a16="http://schemas.microsoft.com/office/drawing/2014/main" id="{BBA8C7A0-3F8C-420E-B75F-9D086D5FCB53}"/>
+                <a16:creationId xmlns:a16="http://schemas.microsoft.com/office/drawing/2014/main" id="{5B3D994E-7351-4AE7-BCDB-5BD9BA887D31}"/>
               </a:ext>
             </a:extLst>
           </p:cNvPr>
@@ -10636,7 +10604,7 @@
           <p:cNvPr id="2" name="">
             <a:extLst xmlns:a="http://schemas.openxmlformats.org/drawingml/2006/main">
               <a:ext uri="{FF2B5EF4-FFF2-40B4-BE49-F238E27FC236}">
-                <a16:creationId xmlns:a16="http://schemas.microsoft.com/office/drawing/2014/main" id="{4CCD89ED-EE17-461B-9416-637E34EC16E1}"/>
+                <a16:creationId xmlns:a16="http://schemas.microsoft.com/office/drawing/2014/main" id="{D1CD576A-4EEF-4E04-A930-3281F07A9EC2}"/>
               </a:ext>
             </a:extLst>
           </p:cNvPr>
@@ -10667,7 +10635,7 @@
           <p:cNvPr id="3" name="">
             <a:extLst xmlns:a="http://schemas.openxmlformats.org/drawingml/2006/main">
               <a:ext uri="{FF2B5EF4-FFF2-40B4-BE49-F238E27FC236}">
-                <a16:creationId xmlns:a16="http://schemas.microsoft.com/office/drawing/2014/main" id="{CA7DDC00-86B5-4C95-A6FB-B55DD8D8C134}"/>
+                <a16:creationId xmlns:a16="http://schemas.microsoft.com/office/drawing/2014/main" id="{6D71451B-3502-48A4-BABA-160E48EF5C48}"/>
               </a:ext>
             </a:extLst>
           </p:cNvPr>
@@ -10723,7 +10691,7 @@
           <p:cNvPr id="4" name="">
             <a:extLst xmlns:a="http://schemas.openxmlformats.org/drawingml/2006/main">
               <a:ext uri="{FF2B5EF4-FFF2-40B4-BE49-F238E27FC236}">
-                <a16:creationId xmlns:a16="http://schemas.microsoft.com/office/drawing/2014/main" id="{BD76793E-4B21-46E0-9D1C-148062D335D0}"/>
+                <a16:creationId xmlns:a16="http://schemas.microsoft.com/office/drawing/2014/main" id="{A85AFAA5-343B-44B3-BDB5-3C2A1CB9A888}"/>
               </a:ext>
             </a:extLst>
           </p:cNvPr>
@@ -10754,7 +10722,7 @@
           <p:cNvPr id="5" name="">
             <a:extLst xmlns:a="http://schemas.openxmlformats.org/drawingml/2006/main">
               <a:ext uri="{FF2B5EF4-FFF2-40B4-BE49-F238E27FC236}">
-                <a16:creationId xmlns:a16="http://schemas.microsoft.com/office/drawing/2014/main" id="{77390D1B-801B-4501-878B-4E4F7324A414}"/>
+                <a16:creationId xmlns:a16="http://schemas.microsoft.com/office/drawing/2014/main" id="{1A58707D-5116-45E3-A59F-A979571E995B}"/>
               </a:ext>
             </a:extLst>
           </p:cNvPr>
@@ -10810,7 +10778,7 @@
           <p:cNvPr id="6" name="">
             <a:extLst xmlns:a="http://schemas.openxmlformats.org/drawingml/2006/main">
               <a:ext uri="{FF2B5EF4-FFF2-40B4-BE49-F238E27FC236}">
-                <a16:creationId xmlns:a16="http://schemas.microsoft.com/office/drawing/2014/main" id="{5C8BB3BE-2476-47EF-B023-6C36F7D8EB89}"/>
+                <a16:creationId xmlns:a16="http://schemas.microsoft.com/office/drawing/2014/main" id="{0BA66C93-DDFB-4BEF-9203-19A7E713CC9A}"/>
               </a:ext>
             </a:extLst>
           </p:cNvPr>
@@ -10866,7 +10834,7 @@
           <p:cNvPr id="7" name="">
             <a:extLst xmlns:a="http://schemas.openxmlformats.org/drawingml/2006/main">
               <a:ext uri="{FF2B5EF4-FFF2-40B4-BE49-F238E27FC236}">
-                <a16:creationId xmlns:a16="http://schemas.microsoft.com/office/drawing/2014/main" id="{159D11B2-23A7-496F-BBE3-0799D51BB3D6}"/>
+                <a16:creationId xmlns:a16="http://schemas.microsoft.com/office/drawing/2014/main" id="{E1C896F0-B57F-4414-A761-71C337A2E3F4}"/>
               </a:ext>
             </a:extLst>
           </p:cNvPr>
@@ -10897,7 +10865,7 @@
           <p:cNvPr id="8" name="">
             <a:extLst xmlns:a="http://schemas.openxmlformats.org/drawingml/2006/main">
               <a:ext uri="{FF2B5EF4-FFF2-40B4-BE49-F238E27FC236}">
-                <a16:creationId xmlns:a16="http://schemas.microsoft.com/office/drawing/2014/main" id="{BE887AC9-CD12-4A3B-8691-14F252848033}"/>
+                <a16:creationId xmlns:a16="http://schemas.microsoft.com/office/drawing/2014/main" id="{67FCD416-8EBE-4160-841E-6952591543E1}"/>
               </a:ext>
             </a:extLst>
           </p:cNvPr>
@@ -10953,7 +10921,7 @@
           <p:cNvPr id="9" name="">
             <a:extLst xmlns:a="http://schemas.openxmlformats.org/drawingml/2006/main">
               <a:ext uri="{FF2B5EF4-FFF2-40B4-BE49-F238E27FC236}">
-                <a16:creationId xmlns:a16="http://schemas.microsoft.com/office/drawing/2014/main" id="{251C5AE1-6B66-4C17-9E7B-FB540899C3EC}"/>
+                <a16:creationId xmlns:a16="http://schemas.microsoft.com/office/drawing/2014/main" id="{1D38AF59-EB8A-4C67-899C-95167379649A}"/>
               </a:ext>
             </a:extLst>
           </p:cNvPr>
@@ -11009,7 +10977,7 @@
           <p:cNvPr id="10" name="">
             <a:extLst xmlns:a="http://schemas.openxmlformats.org/drawingml/2006/main">
               <a:ext uri="{FF2B5EF4-FFF2-40B4-BE49-F238E27FC236}">
-                <a16:creationId xmlns:a16="http://schemas.microsoft.com/office/drawing/2014/main" id="{5AEC3A88-3FA0-41F6-B5A6-E8510B7D6C71}"/>
+                <a16:creationId xmlns:a16="http://schemas.microsoft.com/office/drawing/2014/main" id="{BB0C806B-92C5-4DD1-8F0A-5ED80D4D776B}"/>
               </a:ext>
             </a:extLst>
           </p:cNvPr>
@@ -11040,7 +11008,7 @@
           <p:cNvPr id="11" name="">
             <a:extLst xmlns:a="http://schemas.openxmlformats.org/drawingml/2006/main">
               <a:ext uri="{FF2B5EF4-FFF2-40B4-BE49-F238E27FC236}">
-                <a16:creationId xmlns:a16="http://schemas.microsoft.com/office/drawing/2014/main" id="{5229B7FA-A97D-4861-ABA7-5707EBBE183B}"/>
+                <a16:creationId xmlns:a16="http://schemas.microsoft.com/office/drawing/2014/main" id="{FE2DF0F6-5BB9-47B6-9869-A7E35F9044DA}"/>
               </a:ext>
             </a:extLst>
           </p:cNvPr>
@@ -11096,7 +11064,7 @@
           <p:cNvPr id="12" name="">
             <a:extLst xmlns:a="http://schemas.openxmlformats.org/drawingml/2006/main">
               <a:ext uri="{FF2B5EF4-FFF2-40B4-BE49-F238E27FC236}">
-                <a16:creationId xmlns:a16="http://schemas.microsoft.com/office/drawing/2014/main" id="{A152E1BE-A450-4833-941F-47FCE5EE70DA}"/>
+                <a16:creationId xmlns:a16="http://schemas.microsoft.com/office/drawing/2014/main" id="{1ABE8E31-23AA-45B0-9599-7D1FE3862B1A}"/>
               </a:ext>
             </a:extLst>
           </p:cNvPr>
@@ -11152,7 +11120,7 @@
           <p:cNvPr id="13" name="">
             <a:extLst xmlns:a="http://schemas.openxmlformats.org/drawingml/2006/main">
               <a:ext uri="{FF2B5EF4-FFF2-40B4-BE49-F238E27FC236}">
-                <a16:creationId xmlns:a16="http://schemas.microsoft.com/office/drawing/2014/main" id="{26C0604C-1FDC-4236-B8F0-473E757EBF42}"/>
+                <a16:creationId xmlns:a16="http://schemas.microsoft.com/office/drawing/2014/main" id="{24743199-FA86-407F-B62D-F932BD29ED72}"/>
               </a:ext>
             </a:extLst>
           </p:cNvPr>
@@ -11183,7 +11151,7 @@
           <p:cNvPr id="14" name="">
             <a:extLst xmlns:a="http://schemas.openxmlformats.org/drawingml/2006/main">
               <a:ext uri="{FF2B5EF4-FFF2-40B4-BE49-F238E27FC236}">
-                <a16:creationId xmlns:a16="http://schemas.microsoft.com/office/drawing/2014/main" id="{92E6CC05-DC35-4637-9166-80739932B049}"/>
+                <a16:creationId xmlns:a16="http://schemas.microsoft.com/office/drawing/2014/main" id="{CCE631C9-21DC-41C9-8715-12DB55248B22}"/>
               </a:ext>
             </a:extLst>
           </p:cNvPr>
@@ -11239,7 +11207,7 @@
           <p:cNvPr id="15" name="">
             <a:extLst xmlns:a="http://schemas.openxmlformats.org/drawingml/2006/main">
               <a:ext uri="{FF2B5EF4-FFF2-40B4-BE49-F238E27FC236}">
-                <a16:creationId xmlns:a16="http://schemas.microsoft.com/office/drawing/2014/main" id="{B35EBB55-C6B1-4752-9DB2-FBB10F07DBF0}"/>
+                <a16:creationId xmlns:a16="http://schemas.microsoft.com/office/drawing/2014/main" id="{D06B6E67-3BAC-4A36-9E2D-596DEEDB4E65}"/>
               </a:ext>
             </a:extLst>
           </p:cNvPr>
@@ -11270,7 +11238,7 @@
           <p:cNvPr id="16" name="">
             <a:extLst xmlns:a="http://schemas.openxmlformats.org/drawingml/2006/main">
               <a:ext uri="{FF2B5EF4-FFF2-40B4-BE49-F238E27FC236}">
-                <a16:creationId xmlns:a16="http://schemas.microsoft.com/office/drawing/2014/main" id="{F8CB474A-D49B-40AA-9E31-DB21078CDDB6}"/>
+                <a16:creationId xmlns:a16="http://schemas.microsoft.com/office/drawing/2014/main" id="{CEDF3CA1-8316-4E43-BC5A-CBC0D96240BC}"/>
               </a:ext>
             </a:extLst>
           </p:cNvPr>
@@ -11326,7 +11294,7 @@
           <p:cNvPr id="17" name="">
             <a:extLst xmlns:a="http://schemas.openxmlformats.org/drawingml/2006/main">
               <a:ext uri="{FF2B5EF4-FFF2-40B4-BE49-F238E27FC236}">
-                <a16:creationId xmlns:a16="http://schemas.microsoft.com/office/drawing/2014/main" id="{315CAFA0-3950-477D-936A-B2EBF28B970E}"/>
+                <a16:creationId xmlns:a16="http://schemas.microsoft.com/office/drawing/2014/main" id="{422D3A18-B895-4745-BFD5-9E99B3F2873D}"/>
               </a:ext>
             </a:extLst>
           </p:cNvPr>
@@ -11357,7 +11325,7 @@
           <p:cNvPr id="18" name="">
             <a:extLst xmlns:a="http://schemas.openxmlformats.org/drawingml/2006/main">
               <a:ext uri="{FF2B5EF4-FFF2-40B4-BE49-F238E27FC236}">
-                <a16:creationId xmlns:a16="http://schemas.microsoft.com/office/drawing/2014/main" id="{C7CBAD2F-F4E3-4881-9926-5FB7BDD0EE56}"/>
+                <a16:creationId xmlns:a16="http://schemas.microsoft.com/office/drawing/2014/main" id="{C178D485-0E63-4789-BE16-D4670A518C57}"/>
               </a:ext>
             </a:extLst>
           </p:cNvPr>
@@ -11411,7 +11379,7 @@
     </p:spTree>
     <p:extLst>
       <p:ext uri="{BB962C8B-B14F-4D97-AF65-F5344CB8AC3E}">
-        <p14:creationId xmlns:p14="http://schemas.microsoft.com/office/powerpoint/2010/main" val="1357558452"/>
+        <p14:creationId xmlns:p14="http://schemas.microsoft.com/office/powerpoint/2010/main" val="1058480390"/>
       </p:ext>
     </p:extLst>
   </p:cSld>
@@ -11442,7 +11410,7 @@
           <p:cNvPr id="1" name="">
             <a:extLst xmlns:a="http://schemas.openxmlformats.org/drawingml/2006/main">
               <a:ext uri="{FF2B5EF4-FFF2-40B4-BE49-F238E27FC236}">
-                <a16:creationId xmlns:a16="http://schemas.microsoft.com/office/drawing/2014/main" id="{AAF947B0-A3E1-41E9-8E3B-4850F1118E10}"/>
+                <a16:creationId xmlns:a16="http://schemas.microsoft.com/office/drawing/2014/main" id="{89F988BD-311A-4A0F-8E1D-0530015AD732}"/>
               </a:ext>
             </a:extLst>
           </p:cNvPr>
@@ -11498,7 +11466,7 @@
           <p:cNvPr id="2" name="">
             <a:extLst xmlns:a="http://schemas.openxmlformats.org/drawingml/2006/main">
               <a:ext uri="{FF2B5EF4-FFF2-40B4-BE49-F238E27FC236}">
-                <a16:creationId xmlns:a16="http://schemas.microsoft.com/office/drawing/2014/main" id="{71C3A0E3-4ADA-4CDB-B42A-D37A7F8B0292}"/>
+                <a16:creationId xmlns:a16="http://schemas.microsoft.com/office/drawing/2014/main" id="{D0D2E44E-BDC1-4E91-BB3F-E24087F43D0B}"/>
               </a:ext>
             </a:extLst>
           </p:cNvPr>
@@ -11529,7 +11497,7 @@
           <p:cNvPr id="3" name="">
             <a:extLst xmlns:a="http://schemas.openxmlformats.org/drawingml/2006/main">
               <a:ext uri="{FF2B5EF4-FFF2-40B4-BE49-F238E27FC236}">
-                <a16:creationId xmlns:a16="http://schemas.microsoft.com/office/drawing/2014/main" id="{99747A1F-2B6D-424A-815F-A57DCE4F927A}"/>
+                <a16:creationId xmlns:a16="http://schemas.microsoft.com/office/drawing/2014/main" id="{BD1B0C31-48AA-4F41-9321-7368ABACF545}"/>
               </a:ext>
             </a:extLst>
           </p:cNvPr>
@@ -11585,7 +11553,7 @@
           <p:cNvPr id="4" name="">
             <a:extLst xmlns:a="http://schemas.openxmlformats.org/drawingml/2006/main">
               <a:ext uri="{FF2B5EF4-FFF2-40B4-BE49-F238E27FC236}">
-                <a16:creationId xmlns:a16="http://schemas.microsoft.com/office/drawing/2014/main" id="{69C91FFD-0161-4B23-9863-BC4379971BB0}"/>
+                <a16:creationId xmlns:a16="http://schemas.microsoft.com/office/drawing/2014/main" id="{A7929FD5-1209-4FD4-B65D-B7D69A155D4C}"/>
               </a:ext>
             </a:extLst>
           </p:cNvPr>
@@ -11641,7 +11609,7 @@
           <p:cNvPr id="5" name="">
             <a:extLst xmlns:a="http://schemas.openxmlformats.org/drawingml/2006/main">
               <a:ext uri="{FF2B5EF4-FFF2-40B4-BE49-F238E27FC236}">
-                <a16:creationId xmlns:a16="http://schemas.microsoft.com/office/drawing/2014/main" id="{282641CA-ADF5-4411-8B9A-62F2B7A1DB23}"/>
+                <a16:creationId xmlns:a16="http://schemas.microsoft.com/office/drawing/2014/main" id="{7B0C672D-3726-4BC8-A196-F5FC282E2027}"/>
               </a:ext>
             </a:extLst>
           </p:cNvPr>
@@ -11672,7 +11640,7 @@
           <p:cNvPr id="6" name="">
             <a:extLst xmlns:a="http://schemas.openxmlformats.org/drawingml/2006/main">
               <a:ext uri="{FF2B5EF4-FFF2-40B4-BE49-F238E27FC236}">
-                <a16:creationId xmlns:a16="http://schemas.microsoft.com/office/drawing/2014/main" id="{2D46FE0B-5BD5-4300-A443-7FBB439F6C0E}"/>
+                <a16:creationId xmlns:a16="http://schemas.microsoft.com/office/drawing/2014/main" id="{268E9377-8F80-4B6E-B4BC-57691D571074}"/>
               </a:ext>
             </a:extLst>
           </p:cNvPr>
@@ -11728,7 +11696,7 @@
           <p:cNvPr id="7" name="">
             <a:extLst xmlns:a="http://schemas.openxmlformats.org/drawingml/2006/main">
               <a:ext uri="{FF2B5EF4-FFF2-40B4-BE49-F238E27FC236}">
-                <a16:creationId xmlns:a16="http://schemas.microsoft.com/office/drawing/2014/main" id="{E2476346-CE9C-4ED6-9E40-6EEFD58E7089}"/>
+                <a16:creationId xmlns:a16="http://schemas.microsoft.com/office/drawing/2014/main" id="{652FC5DF-2C48-4E34-8FCA-E689B3A29453}"/>
               </a:ext>
             </a:extLst>
           </p:cNvPr>
@@ -11759,7 +11727,7 @@
           <p:cNvPr id="8" name="">
             <a:extLst xmlns:a="http://schemas.openxmlformats.org/drawingml/2006/main">
               <a:ext uri="{FF2B5EF4-FFF2-40B4-BE49-F238E27FC236}">
-                <a16:creationId xmlns:a16="http://schemas.microsoft.com/office/drawing/2014/main" id="{D6EA8B2B-2376-4583-931C-EB4D2544DA93}"/>
+                <a16:creationId xmlns:a16="http://schemas.microsoft.com/office/drawing/2014/main" id="{109BFCF3-94D8-4055-9E5B-29BD227D8C7A}"/>
               </a:ext>
             </a:extLst>
           </p:cNvPr>
@@ -11815,7 +11783,7 @@
           <p:cNvPr id="9" name="">
             <a:extLst xmlns:a="http://schemas.openxmlformats.org/drawingml/2006/main">
               <a:ext uri="{FF2B5EF4-FFF2-40B4-BE49-F238E27FC236}">
-                <a16:creationId xmlns:a16="http://schemas.microsoft.com/office/drawing/2014/main" id="{260C7975-4E06-4F6E-8ADA-01A2E34CA2A3}"/>
+                <a16:creationId xmlns:a16="http://schemas.microsoft.com/office/drawing/2014/main" id="{934DDB0C-9E5F-496C-B62E-75F326BB3C45}"/>
               </a:ext>
             </a:extLst>
           </p:cNvPr>
@@ -11846,7 +11814,7 @@
           <p:cNvPr id="10" name="">
             <a:extLst xmlns:a="http://schemas.openxmlformats.org/drawingml/2006/main">
               <a:ext uri="{FF2B5EF4-FFF2-40B4-BE49-F238E27FC236}">
-                <a16:creationId xmlns:a16="http://schemas.microsoft.com/office/drawing/2014/main" id="{002F01A2-F36F-4AD4-8D0E-49BBE1531AC9}"/>
+                <a16:creationId xmlns:a16="http://schemas.microsoft.com/office/drawing/2014/main" id="{809B4EB6-BAA3-43A7-B344-14FD63D4B907}"/>
               </a:ext>
             </a:extLst>
           </p:cNvPr>
@@ -11902,7 +11870,7 @@
           <p:cNvPr id="11" name="">
             <a:extLst xmlns:a="http://schemas.openxmlformats.org/drawingml/2006/main">
               <a:ext uri="{FF2B5EF4-FFF2-40B4-BE49-F238E27FC236}">
-                <a16:creationId xmlns:a16="http://schemas.microsoft.com/office/drawing/2014/main" id="{21F6F629-B3F3-47CA-B4DC-D16768EBF422}"/>
+                <a16:creationId xmlns:a16="http://schemas.microsoft.com/office/drawing/2014/main" id="{8BB4667E-6476-4E38-B02A-52F3E186F47E}"/>
               </a:ext>
             </a:extLst>
           </p:cNvPr>
@@ -11933,7 +11901,7 @@
           <p:cNvPr id="12" name="">
             <a:extLst xmlns:a="http://schemas.openxmlformats.org/drawingml/2006/main">
               <a:ext uri="{FF2B5EF4-FFF2-40B4-BE49-F238E27FC236}">
-                <a16:creationId xmlns:a16="http://schemas.microsoft.com/office/drawing/2014/main" id="{18F69266-F6AC-46FA-A923-80D49CAFEBA3}"/>
+                <a16:creationId xmlns:a16="http://schemas.microsoft.com/office/drawing/2014/main" id="{B7D8B756-5FAF-44D3-925C-4168A45CAAD8}"/>
               </a:ext>
             </a:extLst>
           </p:cNvPr>
@@ -11989,7 +11957,7 @@
           <p:cNvPr id="13" name="">
             <a:extLst xmlns:a="http://schemas.openxmlformats.org/drawingml/2006/main">
               <a:ext uri="{FF2B5EF4-FFF2-40B4-BE49-F238E27FC236}">
-                <a16:creationId xmlns:a16="http://schemas.microsoft.com/office/drawing/2014/main" id="{05DD0B67-86EB-4008-88B4-6E41D7B989E7}"/>
+                <a16:creationId xmlns:a16="http://schemas.microsoft.com/office/drawing/2014/main" id="{E919A03A-CB7F-418D-A04B-09326C695918}"/>
               </a:ext>
             </a:extLst>
           </p:cNvPr>
@@ -12020,7 +11988,7 @@
           <p:cNvPr id="14" name="">
             <a:extLst xmlns:a="http://schemas.openxmlformats.org/drawingml/2006/main">
               <a:ext uri="{FF2B5EF4-FFF2-40B4-BE49-F238E27FC236}">
-                <a16:creationId xmlns:a16="http://schemas.microsoft.com/office/drawing/2014/main" id="{CB7F6AAF-EC1E-408B-BED5-B22907C9E68E}"/>
+                <a16:creationId xmlns:a16="http://schemas.microsoft.com/office/drawing/2014/main" id="{E5AFCE36-AAB5-4F9A-8A88-66AA64994482}"/>
               </a:ext>
             </a:extLst>
           </p:cNvPr>
@@ -12076,7 +12044,7 @@
           <p:cNvPr id="15" name="">
             <a:extLst xmlns:a="http://schemas.openxmlformats.org/drawingml/2006/main">
               <a:ext uri="{FF2B5EF4-FFF2-40B4-BE49-F238E27FC236}">
-                <a16:creationId xmlns:a16="http://schemas.microsoft.com/office/drawing/2014/main" id="{2648BCF9-B472-4DEA-8261-95F07C04BC30}"/>
+                <a16:creationId xmlns:a16="http://schemas.microsoft.com/office/drawing/2014/main" id="{C51F2570-2E83-4021-8B32-C76607430B4A}"/>
               </a:ext>
             </a:extLst>
           </p:cNvPr>
@@ -12130,7 +12098,7 @@
     </p:spTree>
     <p:extLst>
       <p:ext uri="{BB962C8B-B14F-4D97-AF65-F5344CB8AC3E}">
-        <p14:creationId xmlns:p14="http://schemas.microsoft.com/office/powerpoint/2010/main" val="1195800601"/>
+        <p14:creationId xmlns:p14="http://schemas.microsoft.com/office/powerpoint/2010/main" val="1355572888"/>
       </p:ext>
     </p:extLst>
   </p:cSld>

</xml_diff>